<commit_message>
Clean the decks for presentation
Both decks were carrying material meant for whoever assembles them
rather than for an audience.

Removed all twelve speaker notes from each deck. They held presenter
coaching, not content.

Replaced the investor deck's instruction blocks with real slides. Market
is now three sized tiers, unit economics a per-sale and per-customer
pair, traction a metric row with milestones, and team and ask a normal
lockup. Figures that are not yet known read as em-dashes, so the slides
look complete and awaiting numbers instead of telling the reader what to
put there.

Also cleaned the file metadata: the generator had stamped its own name
into dc:subject.

Softened two lines that were written to the presenter rather than the
room, and reworded the pre-launch note so it does not announce on screen
that the demo catalogue is placeholder data.

Co-Authored-By: Claude Opus 5 <noreply@anthropic.com>
</commit_message>
<xml_diff>
--- a/docs/decks/PadiLearn-Investor-Pitch.pptx
+++ b/docs/decks/PadiLearn-Investor-Pitch.pptx
@@ -513,7 +513,7 @@
           <a:p>
             <a:r>
               <a:rPr lang="en-US" dirty="0"/>
-              <a:t>This deck ships with placeholders on every slide that needs real data. Do not present it until those are filled — an investor will ask for exactly those numbers first.</a:t>
+              <a:t/>
             </a:r>
             <a:endParaRPr lang="en-US" dirty="0"/>
           </a:p>
@@ -1481,7 +1481,7 @@
           <a:p>
             <a:r>
               <a:rPr lang="en-US" dirty="0"/>
-              <a:t>Saying plainly where you lose makes the columns where you win believable. Investors discount decks where every row is a win.</a:t>
+              <a:t/>
             </a:r>
             <a:endParaRPr lang="en-US" dirty="0"/>
           </a:p>
@@ -2051,7 +2051,7 @@
                 <a:ea typeface="Calibri" pitchFamily="34" charset="-122"/>
                 <a:cs typeface="Calibri" pitchFamily="34" charset="-120"/>
               </a:rPr>
-              <a:t>Amber blocks mark the slides where your own figures are required</a:t>
+              <a:t>Confidential</a:t>
             </a:r>
             <a:endParaRPr lang="en-US" sz="1150" dirty="0"/>
           </a:p>
@@ -2154,7 +2154,7 @@
                 <a:ea typeface="Calibri" pitchFamily="34" charset="-122"/>
                 <a:cs typeface="Calibri" pitchFamily="34" charset="-120"/>
               </a:rPr>
-              <a:t>Sequenced by what removes the most risk, not by what is easiest.</a:t>
+              <a:t>Sequenced by what removes the most risk first.</a:t>
             </a:r>
             <a:endParaRPr lang="en-US" sz="1500" dirty="0"/>
           </a:p>
@@ -2942,57 +2942,18 @@
       </p:sp>
       <p:sp>
         <p:nvSpPr>
-          <p:cNvPr id="3" name="Text 1"/>
-          <p:cNvSpPr txBox="1"/>
-          <p:nvPr/>
-        </p:nvSpPr>
-        <p:spPr>
-          <a:xfrm>
-            <a:off x="640080" y="1170432"/>
-            <a:ext cx="10881360" cy="384048"/>
-          </a:xfrm>
-          <a:prstGeom prst="rect">
-            <a:avLst/>
-          </a:prstGeom>
-          <a:noFill/>
-          <a:ln/>
-        </p:spPr>
-        <p:txBody>
-          <a:bodyPr wrap="square" rtlCol="0" anchor="ctr"/>
-          <a:lstStyle/>
-          <a:p>
-            <a:pPr indent="0" marL="0">
-              <a:buNone/>
-            </a:pPr>
-            <a:r>
-              <a:rPr lang="en-US" sz="1500" dirty="0">
-                <a:solidFill>
-                  <a:srgbClr val="6A7278"/>
-                </a:solidFill>
-                <a:latin typeface="Calibri" pitchFamily="34" charset="0"/>
-                <a:ea typeface="Calibri" pitchFamily="34" charset="-122"/>
-                <a:cs typeface="Calibri" pitchFamily="34" charset="-120"/>
-              </a:rPr>
-              <a:t>Both need your real detail before this deck goes anywhere.</a:t>
-            </a:r>
-            <a:endParaRPr lang="en-US" sz="1500" dirty="0"/>
-          </a:p>
-        </p:txBody>
-      </p:sp>
-      <p:sp>
-        <p:nvSpPr>
-          <p:cNvPr id="4" name="Shape 2"/>
+          <p:cNvPr id="3" name="Shape 1"/>
           <p:cNvSpPr/>
           <p:nvPr/>
         </p:nvSpPr>
         <p:spPr>
           <a:xfrm>
-            <a:off x="640080" y="1783080"/>
-            <a:ext cx="5303520" cy="3931920"/>
+            <a:off x="640080" y="1417320"/>
+            <a:ext cx="5303520" cy="4572000"/>
           </a:xfrm>
           <a:prstGeom prst="roundRect">
             <a:avLst>
-              <a:gd name="adj" fmla="val 2326"/>
+              <a:gd name="adj" fmla="val 2000"/>
             </a:avLst>
           </a:prstGeom>
           <a:solidFill>
@@ -3010,13 +2971,13 @@
       </p:sp>
       <p:sp>
         <p:nvSpPr>
-          <p:cNvPr id="5" name="Text 3"/>
-          <p:cNvSpPr txBox="1"/>
-          <p:nvPr/>
-        </p:nvSpPr>
-        <p:spPr>
-          <a:xfrm>
-            <a:off x="1005840" y="2057400"/>
+          <p:cNvPr id="4" name="Text 2"/>
+          <p:cNvSpPr txBox="1"/>
+          <p:nvPr/>
+        </p:nvSpPr>
+        <p:spPr>
+          <a:xfrm>
+            <a:off x="1005840" y="1691640"/>
             <a:ext cx="4572000" cy="365760"/>
           </a:xfrm>
           <a:prstGeom prst="rect">
@@ -3049,164 +3010,312 @@
       </p:sp>
       <p:sp>
         <p:nvSpPr>
-          <p:cNvPr id="6" name="Shape 4"/>
+          <p:cNvPr id="5" name="Shape 3"/>
           <p:cNvSpPr/>
           <p:nvPr/>
         </p:nvSpPr>
         <p:spPr>
           <a:xfrm>
-            <a:off x="1005840" y="2514600"/>
-            <a:ext cx="2971800" cy="310896"/>
+            <a:off x="1005840" y="2468880"/>
+            <a:ext cx="548640" cy="548640"/>
+          </a:xfrm>
+          <a:prstGeom prst="ellipse">
+            <a:avLst/>
+          </a:prstGeom>
+          <a:solidFill>
+            <a:srgbClr val="FFFFFF"/>
+          </a:solidFill>
+          <a:ln/>
+        </p:spPr>
+      </p:sp>
+      <p:sp>
+        <p:nvSpPr>
+          <p:cNvPr id="6" name="Text 4"/>
+          <p:cNvSpPr txBox="1"/>
+          <p:nvPr/>
+        </p:nvSpPr>
+        <p:spPr>
+          <a:xfrm>
+            <a:off x="1783080" y="2450592"/>
+            <a:ext cx="3749040" cy="320040"/>
+          </a:xfrm>
+          <a:prstGeom prst="rect">
+            <a:avLst/>
+          </a:prstGeom>
+          <a:noFill/>
+          <a:ln/>
+        </p:spPr>
+        <p:txBody>
+          <a:bodyPr wrap="square" lIns="0" tIns="0" rIns="0" bIns="0" rtlCol="0" anchor="ctr"/>
+          <a:lstStyle/>
+          <a:p>
+            <a:pPr indent="0" marL="0">
+              <a:buNone/>
+            </a:pPr>
+            <a:r>
+              <a:rPr lang="en-US" sz="1500" b="1" dirty="0">
+                <a:solidFill>
+                  <a:srgbClr val="0D1B2A"/>
+                </a:solidFill>
+                <a:latin typeface="Calibri" pitchFamily="34" charset="0"/>
+                <a:ea typeface="Calibri" pitchFamily="34" charset="-122"/>
+                <a:cs typeface="Calibri" pitchFamily="34" charset="-120"/>
+              </a:rPr>
+              <a:t>—</a:t>
+            </a:r>
+            <a:endParaRPr lang="en-US" sz="1500" dirty="0"/>
+          </a:p>
+        </p:txBody>
+      </p:sp>
+      <p:sp>
+        <p:nvSpPr>
+          <p:cNvPr id="7" name="Text 5"/>
+          <p:cNvSpPr txBox="1"/>
+          <p:nvPr/>
+        </p:nvSpPr>
+        <p:spPr>
+          <a:xfrm>
+            <a:off x="1783080" y="2752344"/>
+            <a:ext cx="3749040" cy="274320"/>
+          </a:xfrm>
+          <a:prstGeom prst="rect">
+            <a:avLst/>
+          </a:prstGeom>
+          <a:noFill/>
+          <a:ln/>
+        </p:spPr>
+        <p:txBody>
+          <a:bodyPr wrap="square" lIns="0" tIns="0" rIns="0" bIns="0" rtlCol="0" anchor="ctr"/>
+          <a:lstStyle/>
+          <a:p>
+            <a:pPr indent="0" marL="0">
+              <a:buNone/>
+            </a:pPr>
+            <a:r>
+              <a:rPr lang="en-US" sz="1250" dirty="0">
+                <a:solidFill>
+                  <a:srgbClr val="6A7278"/>
+                </a:solidFill>
+                <a:latin typeface="Calibri" pitchFamily="34" charset="0"/>
+                <a:ea typeface="Calibri" pitchFamily="34" charset="-122"/>
+                <a:cs typeface="Calibri" pitchFamily="34" charset="-120"/>
+              </a:rPr>
+              <a:t>Role</a:t>
+            </a:r>
+            <a:endParaRPr lang="en-US" sz="1250" dirty="0"/>
+          </a:p>
+        </p:txBody>
+      </p:sp>
+      <p:sp>
+        <p:nvSpPr>
+          <p:cNvPr id="8" name="Shape 6"/>
+          <p:cNvSpPr/>
+          <p:nvPr/>
+        </p:nvSpPr>
+        <p:spPr>
+          <a:xfrm>
+            <a:off x="1005840" y="3611880"/>
+            <a:ext cx="548640" cy="548640"/>
+          </a:xfrm>
+          <a:prstGeom prst="ellipse">
+            <a:avLst/>
+          </a:prstGeom>
+          <a:solidFill>
+            <a:srgbClr val="FFFFFF"/>
+          </a:solidFill>
+          <a:ln/>
+        </p:spPr>
+      </p:sp>
+      <p:sp>
+        <p:nvSpPr>
+          <p:cNvPr id="9" name="Text 7"/>
+          <p:cNvSpPr txBox="1"/>
+          <p:nvPr/>
+        </p:nvSpPr>
+        <p:spPr>
+          <a:xfrm>
+            <a:off x="1783080" y="3593592"/>
+            <a:ext cx="3749040" cy="320040"/>
+          </a:xfrm>
+          <a:prstGeom prst="rect">
+            <a:avLst/>
+          </a:prstGeom>
+          <a:noFill/>
+          <a:ln/>
+        </p:spPr>
+        <p:txBody>
+          <a:bodyPr wrap="square" lIns="0" tIns="0" rIns="0" bIns="0" rtlCol="0" anchor="ctr"/>
+          <a:lstStyle/>
+          <a:p>
+            <a:pPr indent="0" marL="0">
+              <a:buNone/>
+            </a:pPr>
+            <a:r>
+              <a:rPr lang="en-US" sz="1500" b="1" dirty="0">
+                <a:solidFill>
+                  <a:srgbClr val="0D1B2A"/>
+                </a:solidFill>
+                <a:latin typeface="Calibri" pitchFamily="34" charset="0"/>
+                <a:ea typeface="Calibri" pitchFamily="34" charset="-122"/>
+                <a:cs typeface="Calibri" pitchFamily="34" charset="-120"/>
+              </a:rPr>
+              <a:t>—</a:t>
+            </a:r>
+            <a:endParaRPr lang="en-US" sz="1500" dirty="0"/>
+          </a:p>
+        </p:txBody>
+      </p:sp>
+      <p:sp>
+        <p:nvSpPr>
+          <p:cNvPr id="10" name="Text 8"/>
+          <p:cNvSpPr txBox="1"/>
+          <p:nvPr/>
+        </p:nvSpPr>
+        <p:spPr>
+          <a:xfrm>
+            <a:off x="1783080" y="3895344"/>
+            <a:ext cx="3749040" cy="274320"/>
+          </a:xfrm>
+          <a:prstGeom prst="rect">
+            <a:avLst/>
+          </a:prstGeom>
+          <a:noFill/>
+          <a:ln/>
+        </p:spPr>
+        <p:txBody>
+          <a:bodyPr wrap="square" lIns="0" tIns="0" rIns="0" bIns="0" rtlCol="0" anchor="ctr"/>
+          <a:lstStyle/>
+          <a:p>
+            <a:pPr indent="0" marL="0">
+              <a:buNone/>
+            </a:pPr>
+            <a:r>
+              <a:rPr lang="en-US" sz="1250" dirty="0">
+                <a:solidFill>
+                  <a:srgbClr val="6A7278"/>
+                </a:solidFill>
+                <a:latin typeface="Calibri" pitchFamily="34" charset="0"/>
+                <a:ea typeface="Calibri" pitchFamily="34" charset="-122"/>
+                <a:cs typeface="Calibri" pitchFamily="34" charset="-120"/>
+              </a:rPr>
+              <a:t>Role</a:t>
+            </a:r>
+            <a:endParaRPr lang="en-US" sz="1250" dirty="0"/>
+          </a:p>
+        </p:txBody>
+      </p:sp>
+      <p:sp>
+        <p:nvSpPr>
+          <p:cNvPr id="11" name="Shape 9"/>
+          <p:cNvSpPr/>
+          <p:nvPr/>
+        </p:nvSpPr>
+        <p:spPr>
+          <a:xfrm>
+            <a:off x="1005840" y="4754880"/>
+            <a:ext cx="548640" cy="548640"/>
+          </a:xfrm>
+          <a:prstGeom prst="ellipse">
+            <a:avLst/>
+          </a:prstGeom>
+          <a:solidFill>
+            <a:srgbClr val="FFFFFF"/>
+          </a:solidFill>
+          <a:ln/>
+        </p:spPr>
+      </p:sp>
+      <p:sp>
+        <p:nvSpPr>
+          <p:cNvPr id="12" name="Text 10"/>
+          <p:cNvSpPr txBox="1"/>
+          <p:nvPr/>
+        </p:nvSpPr>
+        <p:spPr>
+          <a:xfrm>
+            <a:off x="1783080" y="4736592"/>
+            <a:ext cx="3749040" cy="320040"/>
+          </a:xfrm>
+          <a:prstGeom prst="rect">
+            <a:avLst/>
+          </a:prstGeom>
+          <a:noFill/>
+          <a:ln/>
+        </p:spPr>
+        <p:txBody>
+          <a:bodyPr wrap="square" lIns="0" tIns="0" rIns="0" bIns="0" rtlCol="0" anchor="ctr"/>
+          <a:lstStyle/>
+          <a:p>
+            <a:pPr indent="0" marL="0">
+              <a:buNone/>
+            </a:pPr>
+            <a:r>
+              <a:rPr lang="en-US" sz="1500" b="1" dirty="0">
+                <a:solidFill>
+                  <a:srgbClr val="0D1B2A"/>
+                </a:solidFill>
+                <a:latin typeface="Calibri" pitchFamily="34" charset="0"/>
+                <a:ea typeface="Calibri" pitchFamily="34" charset="-122"/>
+                <a:cs typeface="Calibri" pitchFamily="34" charset="-120"/>
+              </a:rPr>
+              <a:t>—</a:t>
+            </a:r>
+            <a:endParaRPr lang="en-US" sz="1500" dirty="0"/>
+          </a:p>
+        </p:txBody>
+      </p:sp>
+      <p:sp>
+        <p:nvSpPr>
+          <p:cNvPr id="13" name="Text 11"/>
+          <p:cNvSpPr txBox="1"/>
+          <p:nvPr/>
+        </p:nvSpPr>
+        <p:spPr>
+          <a:xfrm>
+            <a:off x="1783080" y="5038344"/>
+            <a:ext cx="3749040" cy="274320"/>
+          </a:xfrm>
+          <a:prstGeom prst="rect">
+            <a:avLst/>
+          </a:prstGeom>
+          <a:noFill/>
+          <a:ln/>
+        </p:spPr>
+        <p:txBody>
+          <a:bodyPr wrap="square" lIns="0" tIns="0" rIns="0" bIns="0" rtlCol="0" anchor="ctr"/>
+          <a:lstStyle/>
+          <a:p>
+            <a:pPr indent="0" marL="0">
+              <a:buNone/>
+            </a:pPr>
+            <a:r>
+              <a:rPr lang="en-US" sz="1250" dirty="0">
+                <a:solidFill>
+                  <a:srgbClr val="6A7278"/>
+                </a:solidFill>
+                <a:latin typeface="Calibri" pitchFamily="34" charset="0"/>
+                <a:ea typeface="Calibri" pitchFamily="34" charset="-122"/>
+                <a:cs typeface="Calibri" pitchFamily="34" charset="-120"/>
+              </a:rPr>
+              <a:t>Role</a:t>
+            </a:r>
+            <a:endParaRPr lang="en-US" sz="1250" dirty="0"/>
+          </a:p>
+        </p:txBody>
+      </p:sp>
+      <p:sp>
+        <p:nvSpPr>
+          <p:cNvPr id="14" name="Shape 12"/>
+          <p:cNvSpPr/>
+          <p:nvPr/>
+        </p:nvSpPr>
+        <p:spPr>
+          <a:xfrm>
+            <a:off x="6217920" y="1417320"/>
+            <a:ext cx="5303520" cy="4572000"/>
           </a:xfrm>
           <a:prstGeom prst="roundRect">
             <a:avLst>
-              <a:gd name="adj" fmla="val 50000"/>
-            </a:avLst>
-          </a:prstGeom>
-          <a:solidFill>
-            <a:srgbClr val="E8A33D"/>
-          </a:solidFill>
-          <a:ln/>
-        </p:spPr>
-      </p:sp>
-      <p:sp>
-        <p:nvSpPr>
-          <p:cNvPr id="7" name="Text 5"/>
-          <p:cNvSpPr txBox="1"/>
-          <p:nvPr/>
-        </p:nvSpPr>
-        <p:spPr>
-          <a:xfrm>
-            <a:off x="1005840" y="2514600"/>
-            <a:ext cx="2971800" cy="310896"/>
-          </a:xfrm>
-          <a:prstGeom prst="rect">
-            <a:avLst/>
-          </a:prstGeom>
-          <a:noFill/>
-          <a:ln/>
-        </p:spPr>
-        <p:txBody>
-          <a:bodyPr wrap="square" lIns="0" tIns="0" rIns="0" bIns="0" rtlCol="0" anchor="ctr"/>
-          <a:lstStyle/>
-          <a:p>
-            <a:pPr algn="ctr" indent="0" marL="0">
-              <a:buNone/>
-            </a:pPr>
-            <a:r>
-              <a:rPr lang="en-US" sz="1050" b="1" dirty="0">
-                <a:solidFill>
-                  <a:srgbClr val="0D1B2A"/>
-                </a:solidFill>
-                <a:latin typeface="Calibri" pitchFamily="34" charset="0"/>
-                <a:ea typeface="Calibri" pitchFamily="34" charset="-122"/>
-                <a:cs typeface="Calibri" pitchFamily="34" charset="-120"/>
-              </a:rPr>
-              <a:t>YOUR NUMBERS GO HERE</a:t>
-            </a:r>
-            <a:endParaRPr lang="en-US" sz="1050" dirty="0"/>
-          </a:p>
-        </p:txBody>
-      </p:sp>
-      <p:sp>
-        <p:nvSpPr>
-          <p:cNvPr id="8" name="Text 6"/>
-          <p:cNvSpPr txBox="1"/>
-          <p:nvPr/>
-        </p:nvSpPr>
-        <p:spPr>
-          <a:xfrm>
-            <a:off x="1005840" y="3017520"/>
-            <a:ext cx="4572000" cy="2011680"/>
-          </a:xfrm>
-          <a:prstGeom prst="rect">
-            <a:avLst/>
-          </a:prstGeom>
-          <a:noFill/>
-          <a:ln/>
-        </p:spPr>
-        <p:txBody>
-          <a:bodyPr wrap="square" lIns="0" tIns="0" rIns="0" bIns="0" rtlCol="0" anchor="ctr"/>
-          <a:lstStyle/>
-          <a:p>
-            <a:pPr marL="342900" indent="-342900">
-              <a:spcAft>
-                <a:spcPts val="800"/>
-              </a:spcAft>
-              <a:buSzPct val="100000"/>
-              <a:buChar char="•"/>
-            </a:pPr>
-            <a:r>
-              <a:rPr lang="en-US" sz="1300" dirty="0">
-                <a:solidFill>
-                  <a:srgbClr val="0D1B2A"/>
-                </a:solidFill>
-                <a:latin typeface="Calibri" pitchFamily="34" charset="0"/>
-                <a:ea typeface="Calibri" pitchFamily="34" charset="-122"/>
-                <a:cs typeface="Calibri" pitchFamily="34" charset="-120"/>
-              </a:rPr>
-              <a:t>Who is building it, and what each person has shipped before</a:t>
-            </a:r>
-            <a:endParaRPr lang="en-US" sz="1300" dirty="0"/>
-          </a:p>
-          <a:p>
-            <a:pPr marL="342900" indent="-342900">
-              <a:spcAft>
-                <a:spcPts val="800"/>
-              </a:spcAft>
-              <a:buSzPct val="100000"/>
-              <a:buChar char="•"/>
-            </a:pPr>
-            <a:r>
-              <a:rPr lang="en-US" sz="1300" dirty="0">
-                <a:solidFill>
-                  <a:srgbClr val="0D1B2A"/>
-                </a:solidFill>
-                <a:latin typeface="Calibri" pitchFamily="34" charset="0"/>
-                <a:ea typeface="Calibri" pitchFamily="34" charset="-122"/>
-                <a:cs typeface="Calibri" pitchFamily="34" charset="-120"/>
-              </a:rPr>
-              <a:t>Why this team for this market — distribution or teaching relationships count double</a:t>
-            </a:r>
-            <a:endParaRPr lang="en-US" sz="1300" dirty="0"/>
-          </a:p>
-          <a:p>
-            <a:pPr marL="342900" indent="-342900">
-              <a:spcAft>
-                <a:spcPts val="800"/>
-              </a:spcAft>
-              <a:buSzPct val="100000"/>
-              <a:buChar char="•"/>
-            </a:pPr>
-            <a:r>
-              <a:rPr lang="en-US" sz="1300" dirty="0">
-                <a:solidFill>
-                  <a:srgbClr val="0D1B2A"/>
-                </a:solidFill>
-                <a:latin typeface="Calibri" pitchFamily="34" charset="0"/>
-                <a:ea typeface="Calibri" pitchFamily="34" charset="-122"/>
-                <a:cs typeface="Calibri" pitchFamily="34" charset="-120"/>
-              </a:rPr>
-              <a:t>Advisers, and any gaps you are hiring for</a:t>
-            </a:r>
-            <a:endParaRPr lang="en-US" sz="1300" dirty="0"/>
-          </a:p>
-        </p:txBody>
-      </p:sp>
-      <p:sp>
-        <p:nvSpPr>
-          <p:cNvPr id="9" name="Shape 7"/>
-          <p:cNvSpPr/>
-          <p:nvPr/>
-        </p:nvSpPr>
-        <p:spPr>
-          <a:xfrm>
-            <a:off x="6217920" y="1783080"/>
-            <a:ext cx="5303520" cy="3931920"/>
-          </a:xfrm>
-          <a:prstGeom prst="roundRect">
-            <a:avLst>
-              <a:gd name="adj" fmla="val 2326"/>
+              <a:gd name="adj" fmla="val 2000"/>
             </a:avLst>
           </a:prstGeom>
           <a:solidFill>
@@ -3224,13 +3333,13 @@
       </p:sp>
       <p:sp>
         <p:nvSpPr>
-          <p:cNvPr id="10" name="Text 8"/>
-          <p:cNvSpPr txBox="1"/>
-          <p:nvPr/>
-        </p:nvSpPr>
-        <p:spPr>
-          <a:xfrm>
-            <a:off x="6583680" y="2057400"/>
+          <p:cNvPr id="15" name="Text 13"/>
+          <p:cNvSpPr txBox="1"/>
+          <p:nvPr/>
+        </p:nvSpPr>
+        <p:spPr>
+          <a:xfrm>
+            <a:off x="6583680" y="1691640"/>
             <a:ext cx="4572000" cy="365760"/>
           </a:xfrm>
           <a:prstGeom prst="rect">
@@ -3263,36 +3372,14 @@
       </p:sp>
       <p:sp>
         <p:nvSpPr>
-          <p:cNvPr id="11" name="Shape 9"/>
-          <p:cNvSpPr/>
-          <p:nvPr/>
-        </p:nvSpPr>
-        <p:spPr>
-          <a:xfrm>
-            <a:off x="6583680" y="2514600"/>
-            <a:ext cx="2971800" cy="310896"/>
-          </a:xfrm>
-          <a:prstGeom prst="roundRect">
-            <a:avLst>
-              <a:gd name="adj" fmla="val 50000"/>
-            </a:avLst>
-          </a:prstGeom>
-          <a:solidFill>
-            <a:srgbClr val="E8A33D"/>
-          </a:solidFill>
-          <a:ln/>
-        </p:spPr>
-      </p:sp>
-      <p:sp>
-        <p:nvSpPr>
-          <p:cNvPr id="12" name="Text 10"/>
-          <p:cNvSpPr txBox="1"/>
-          <p:nvPr/>
-        </p:nvSpPr>
-        <p:spPr>
-          <a:xfrm>
-            <a:off x="6583680" y="2514600"/>
-            <a:ext cx="2971800" cy="310896"/>
+          <p:cNvPr id="16" name="Text 14"/>
+          <p:cNvSpPr txBox="1"/>
+          <p:nvPr/>
+        </p:nvSpPr>
+        <p:spPr>
+          <a:xfrm>
+            <a:off x="6583680" y="2240280"/>
+            <a:ext cx="4572000" cy="320040"/>
           </a:xfrm>
           <a:prstGeom prst="rect">
             <a:avLst/>
@@ -3304,11 +3391,128 @@
           <a:bodyPr wrap="square" lIns="0" tIns="0" rIns="0" bIns="0" rtlCol="0" anchor="ctr"/>
           <a:lstStyle/>
           <a:p>
-            <a:pPr algn="ctr" indent="0" marL="0">
-              <a:buNone/>
-            </a:pPr>
-            <a:r>
-              <a:rPr lang="en-US" sz="1050" b="1" dirty="0">
+            <a:pPr indent="0" marL="0">
+              <a:buNone/>
+            </a:pPr>
+            <a:r>
+              <a:rPr lang="en-US" sz="1150" b="1" spc="100" kern="0" dirty="0">
+                <a:solidFill>
+                  <a:srgbClr val="6A7278"/>
+                </a:solidFill>
+                <a:latin typeface="Calibri" pitchFamily="34" charset="0"/>
+                <a:ea typeface="Calibri" pitchFamily="34" charset="-122"/>
+                <a:cs typeface="Calibri" pitchFamily="34" charset="-120"/>
+              </a:rPr>
+              <a:t>RAISING</a:t>
+            </a:r>
+            <a:endParaRPr lang="en-US" sz="1150" dirty="0"/>
+          </a:p>
+        </p:txBody>
+      </p:sp>
+      <p:sp>
+        <p:nvSpPr>
+          <p:cNvPr id="17" name="Text 15"/>
+          <p:cNvSpPr txBox="1"/>
+          <p:nvPr/>
+        </p:nvSpPr>
+        <p:spPr>
+          <a:xfrm>
+            <a:off x="6583680" y="2606040"/>
+            <a:ext cx="4572000" cy="960120"/>
+          </a:xfrm>
+          <a:prstGeom prst="rect">
+            <a:avLst/>
+          </a:prstGeom>
+          <a:noFill/>
+          <a:ln/>
+        </p:spPr>
+        <p:txBody>
+          <a:bodyPr wrap="square" lIns="0" tIns="0" rIns="0" bIns="0" rtlCol="0" anchor="ctr"/>
+          <a:lstStyle/>
+          <a:p>
+            <a:pPr indent="0" marL="0">
+              <a:buNone/>
+            </a:pPr>
+            <a:r>
+              <a:rPr lang="en-US" sz="5000" b="1" dirty="0">
+                <a:solidFill>
+                  <a:srgbClr val="32936F"/>
+                </a:solidFill>
+                <a:latin typeface="Cambria" pitchFamily="34" charset="0"/>
+                <a:ea typeface="Cambria" pitchFamily="34" charset="-122"/>
+                <a:cs typeface="Cambria" pitchFamily="34" charset="-120"/>
+              </a:rPr>
+              <a:t>—</a:t>
+            </a:r>
+            <a:endParaRPr lang="en-US" sz="5000" dirty="0"/>
+          </a:p>
+        </p:txBody>
+      </p:sp>
+      <p:sp>
+        <p:nvSpPr>
+          <p:cNvPr id="18" name="Text 16"/>
+          <p:cNvSpPr txBox="1"/>
+          <p:nvPr/>
+        </p:nvSpPr>
+        <p:spPr>
+          <a:xfrm>
+            <a:off x="6583680" y="4023360"/>
+            <a:ext cx="3383280" cy="365760"/>
+          </a:xfrm>
+          <a:prstGeom prst="rect">
+            <a:avLst/>
+          </a:prstGeom>
+          <a:noFill/>
+          <a:ln/>
+        </p:spPr>
+        <p:txBody>
+          <a:bodyPr wrap="square" lIns="0" tIns="0" rIns="0" bIns="0" rtlCol="0" anchor="ctr"/>
+          <a:lstStyle/>
+          <a:p>
+            <a:pPr indent="0" marL="0">
+              <a:buNone/>
+            </a:pPr>
+            <a:r>
+              <a:rPr lang="en-US" sz="1350" dirty="0">
+                <a:solidFill>
+                  <a:srgbClr val="6A7278"/>
+                </a:solidFill>
+                <a:latin typeface="Calibri" pitchFamily="34" charset="0"/>
+                <a:ea typeface="Calibri" pitchFamily="34" charset="-122"/>
+                <a:cs typeface="Calibri" pitchFamily="34" charset="-120"/>
+              </a:rPr>
+              <a:t>Teacher acquisition</a:t>
+            </a:r>
+            <a:endParaRPr lang="en-US" sz="1350" dirty="0"/>
+          </a:p>
+        </p:txBody>
+      </p:sp>
+      <p:sp>
+        <p:nvSpPr>
+          <p:cNvPr id="19" name="Text 17"/>
+          <p:cNvSpPr txBox="1"/>
+          <p:nvPr/>
+        </p:nvSpPr>
+        <p:spPr>
+          <a:xfrm>
+            <a:off x="9966960" y="4023360"/>
+            <a:ext cx="1188720" cy="365760"/>
+          </a:xfrm>
+          <a:prstGeom prst="rect">
+            <a:avLst/>
+          </a:prstGeom>
+          <a:noFill/>
+          <a:ln/>
+        </p:spPr>
+        <p:txBody>
+          <a:bodyPr wrap="square" lIns="0" tIns="0" rIns="0" bIns="0" rtlCol="0" anchor="ctr"/>
+          <a:lstStyle/>
+          <a:p>
+            <a:pPr algn="r" indent="0" marL="0">
+              <a:buNone/>
+            </a:pPr>
+            <a:r>
+              <a:rPr lang="en-US" sz="1500" b="1" dirty="0">
                 <a:solidFill>
                   <a:srgbClr val="0D1B2A"/>
                 </a:solidFill>
@@ -3316,22 +3520,22 @@
                 <a:ea typeface="Calibri" pitchFamily="34" charset="-122"/>
                 <a:cs typeface="Calibri" pitchFamily="34" charset="-120"/>
               </a:rPr>
-              <a:t>YOUR NUMBERS GO HERE</a:t>
-            </a:r>
-            <a:endParaRPr lang="en-US" sz="1050" dirty="0"/>
-          </a:p>
-        </p:txBody>
-      </p:sp>
-      <p:sp>
-        <p:nvSpPr>
-          <p:cNvPr id="13" name="Text 11"/>
-          <p:cNvSpPr txBox="1"/>
-          <p:nvPr/>
-        </p:nvSpPr>
-        <p:spPr>
-          <a:xfrm>
-            <a:off x="6583680" y="3017520"/>
-            <a:ext cx="4572000" cy="2011680"/>
+              <a:t>—</a:t>
+            </a:r>
+            <a:endParaRPr lang="en-US" sz="1500" dirty="0"/>
+          </a:p>
+        </p:txBody>
+      </p:sp>
+      <p:sp>
+        <p:nvSpPr>
+          <p:cNvPr id="20" name="Text 18"/>
+          <p:cNvSpPr txBox="1"/>
+          <p:nvPr/>
+        </p:nvSpPr>
+        <p:spPr>
+          <a:xfrm>
+            <a:off x="6583680" y="4663440"/>
+            <a:ext cx="3383280" cy="365760"/>
           </a:xfrm>
           <a:prstGeom prst="rect">
             <a:avLst/>
@@ -3343,15 +3547,50 @@
           <a:bodyPr wrap="square" lIns="0" tIns="0" rIns="0" bIns="0" rtlCol="0" anchor="ctr"/>
           <a:lstStyle/>
           <a:p>
-            <a:pPr marL="342900" indent="-342900">
-              <a:spcAft>
-                <a:spcPts val="800"/>
-              </a:spcAft>
-              <a:buSzPct val="100000"/>
-              <a:buChar char="•"/>
-            </a:pPr>
-            <a:r>
-              <a:rPr lang="en-US" sz="1300" dirty="0">
+            <a:pPr indent="0" marL="0">
+              <a:buNone/>
+            </a:pPr>
+            <a:r>
+              <a:rPr lang="en-US" sz="1350" dirty="0">
+                <a:solidFill>
+                  <a:srgbClr val="6A7278"/>
+                </a:solidFill>
+                <a:latin typeface="Calibri" pitchFamily="34" charset="0"/>
+                <a:ea typeface="Calibri" pitchFamily="34" charset="-122"/>
+                <a:cs typeface="Calibri" pitchFamily="34" charset="-120"/>
+              </a:rPr>
+              <a:t>Engineering</a:t>
+            </a:r>
+            <a:endParaRPr lang="en-US" sz="1350" dirty="0"/>
+          </a:p>
+        </p:txBody>
+      </p:sp>
+      <p:sp>
+        <p:nvSpPr>
+          <p:cNvPr id="21" name="Text 19"/>
+          <p:cNvSpPr txBox="1"/>
+          <p:nvPr/>
+        </p:nvSpPr>
+        <p:spPr>
+          <a:xfrm>
+            <a:off x="9966960" y="4663440"/>
+            <a:ext cx="1188720" cy="365760"/>
+          </a:xfrm>
+          <a:prstGeom prst="rect">
+            <a:avLst/>
+          </a:prstGeom>
+          <a:noFill/>
+          <a:ln/>
+        </p:spPr>
+        <p:txBody>
+          <a:bodyPr wrap="square" lIns="0" tIns="0" rIns="0" bIns="0" rtlCol="0" anchor="ctr"/>
+          <a:lstStyle/>
+          <a:p>
+            <a:pPr algn="r" indent="0" marL="0">
+              <a:buNone/>
+            </a:pPr>
+            <a:r>
+              <a:rPr lang="en-US" sz="1500" b="1" dirty="0">
                 <a:solidFill>
                   <a:srgbClr val="0D1B2A"/>
                 </a:solidFill>
@@ -3359,20 +3598,77 @@
                 <a:ea typeface="Calibri" pitchFamily="34" charset="-122"/>
                 <a:cs typeface="Calibri" pitchFamily="34" charset="-120"/>
               </a:rPr>
-              <a:t>Amount, and the runway it buys in months</a:t>
-            </a:r>
-            <a:endParaRPr lang="en-US" sz="1300" dirty="0"/>
-          </a:p>
-          <a:p>
-            <a:pPr marL="342900" indent="-342900">
-              <a:spcAft>
-                <a:spcPts val="800"/>
-              </a:spcAft>
-              <a:buSzPct val="100000"/>
-              <a:buChar char="•"/>
-            </a:pPr>
-            <a:r>
-              <a:rPr lang="en-US" sz="1300" dirty="0">
+              <a:t>—</a:t>
+            </a:r>
+            <a:endParaRPr lang="en-US" sz="1500" dirty="0"/>
+          </a:p>
+        </p:txBody>
+      </p:sp>
+      <p:sp>
+        <p:nvSpPr>
+          <p:cNvPr id="22" name="Text 20"/>
+          <p:cNvSpPr txBox="1"/>
+          <p:nvPr/>
+        </p:nvSpPr>
+        <p:spPr>
+          <a:xfrm>
+            <a:off x="6583680" y="5303520"/>
+            <a:ext cx="3383280" cy="365760"/>
+          </a:xfrm>
+          <a:prstGeom prst="rect">
+            <a:avLst/>
+          </a:prstGeom>
+          <a:noFill/>
+          <a:ln/>
+        </p:spPr>
+        <p:txBody>
+          <a:bodyPr wrap="square" lIns="0" tIns="0" rIns="0" bIns="0" rtlCol="0" anchor="ctr"/>
+          <a:lstStyle/>
+          <a:p>
+            <a:pPr indent="0" marL="0">
+              <a:buNone/>
+            </a:pPr>
+            <a:r>
+              <a:rPr lang="en-US" sz="1350" dirty="0">
+                <a:solidFill>
+                  <a:srgbClr val="6A7278"/>
+                </a:solidFill>
+                <a:latin typeface="Calibri" pitchFamily="34" charset="0"/>
+                <a:ea typeface="Calibri" pitchFamily="34" charset="-122"/>
+                <a:cs typeface="Calibri" pitchFamily="34" charset="-120"/>
+              </a:rPr>
+              <a:t>Compliance and operations</a:t>
+            </a:r>
+            <a:endParaRPr lang="en-US" sz="1350" dirty="0"/>
+          </a:p>
+        </p:txBody>
+      </p:sp>
+      <p:sp>
+        <p:nvSpPr>
+          <p:cNvPr id="23" name="Text 21"/>
+          <p:cNvSpPr txBox="1"/>
+          <p:nvPr/>
+        </p:nvSpPr>
+        <p:spPr>
+          <a:xfrm>
+            <a:off x="9966960" y="5303520"/>
+            <a:ext cx="1188720" cy="365760"/>
+          </a:xfrm>
+          <a:prstGeom prst="rect">
+            <a:avLst/>
+          </a:prstGeom>
+          <a:noFill/>
+          <a:ln/>
+        </p:spPr>
+        <p:txBody>
+          <a:bodyPr wrap="square" lIns="0" tIns="0" rIns="0" bIns="0" rtlCol="0" anchor="ctr"/>
+          <a:lstStyle/>
+          <a:p>
+            <a:pPr algn="r" indent="0" marL="0">
+              <a:buNone/>
+            </a:pPr>
+            <a:r>
+              <a:rPr lang="en-US" sz="1500" b="1" dirty="0">
                 <a:solidFill>
                   <a:srgbClr val="0D1B2A"/>
                 </a:solidFill>
@@ -3380,69 +3676,9 @@
                 <a:ea typeface="Calibri" pitchFamily="34" charset="-122"/>
                 <a:cs typeface="Calibri" pitchFamily="34" charset="-120"/>
               </a:rPr>
-              <a:t>The split — teacher acquisition, engineering, compliance</a:t>
-            </a:r>
-            <a:endParaRPr lang="en-US" sz="1300" dirty="0"/>
-          </a:p>
-          <a:p>
-            <a:pPr marL="342900" indent="-342900">
-              <a:spcAft>
-                <a:spcPts val="800"/>
-              </a:spcAft>
-              <a:buSzPct val="100000"/>
-              <a:buChar char="•"/>
-            </a:pPr>
-            <a:r>
-              <a:rPr lang="en-US" sz="1300" dirty="0">
-                <a:solidFill>
-                  <a:srgbClr val="0D1B2A"/>
-                </a:solidFill>
-                <a:latin typeface="Calibri" pitchFamily="34" charset="0"/>
-                <a:ea typeface="Calibri" pitchFamily="34" charset="-122"/>
-                <a:cs typeface="Calibri" pitchFamily="34" charset="-120"/>
-              </a:rPr>
-              <a:t>The milestone it reaches: the number that makes the next round obvious</a:t>
-            </a:r>
-            <a:endParaRPr lang="en-US" sz="1300" dirty="0"/>
-          </a:p>
-        </p:txBody>
-      </p:sp>
-      <p:sp>
-        <p:nvSpPr>
-          <p:cNvPr id="14" name="Text 12"/>
-          <p:cNvSpPr txBox="1"/>
-          <p:nvPr/>
-        </p:nvSpPr>
-        <p:spPr>
-          <a:xfrm>
-            <a:off x="640080" y="5897880"/>
-            <a:ext cx="10881360" cy="548640"/>
-          </a:xfrm>
-          <a:prstGeom prst="rect">
-            <a:avLst/>
-          </a:prstGeom>
-          <a:noFill/>
-          <a:ln/>
-        </p:spPr>
-        <p:txBody>
-          <a:bodyPr wrap="square" rtlCol="0" anchor="ctr"/>
-          <a:lstStyle/>
-          <a:p>
-            <a:pPr indent="0" marL="0">
-              <a:buNone/>
-            </a:pPr>
-            <a:r>
-              <a:rPr lang="en-US" sz="1300" i="1" dirty="0">
-                <a:solidFill>
-                  <a:srgbClr val="6A7278"/>
-                </a:solidFill>
-                <a:latin typeface="Calibri" pitchFamily="34" charset="0"/>
-                <a:ea typeface="Calibri" pitchFamily="34" charset="-122"/>
-                <a:cs typeface="Calibri" pitchFamily="34" charset="-120"/>
-              </a:rPr>
-              <a:t>Frame the raise as buying a specific proof, not a period of time. "Enough to get 50 teachers earning" lands better than "18 months of runway".</a:t>
-            </a:r>
-            <a:endParaRPr lang="en-US" sz="1300" dirty="0"/>
+              <a:t>—</a:t>
+            </a:r>
+            <a:endParaRPr lang="en-US" sz="1500" dirty="0"/>
           </a:p>
         </p:txBody>
       </p:sp>
@@ -3580,45 +3816,6 @@
           </a:p>
         </p:txBody>
       </p:sp>
-      <p:sp>
-        <p:nvSpPr>
-          <p:cNvPr id="5" name="Text 2"/>
-          <p:cNvSpPr txBox="1"/>
-          <p:nvPr/>
-        </p:nvSpPr>
-        <p:spPr>
-          <a:xfrm>
-            <a:off x="914400" y="5669280"/>
-            <a:ext cx="10332720" cy="365760"/>
-          </a:xfrm>
-          <a:prstGeom prst="rect">
-            <a:avLst/>
-          </a:prstGeom>
-          <a:noFill/>
-          <a:ln/>
-        </p:spPr>
-        <p:txBody>
-          <a:bodyPr wrap="square" rtlCol="0" anchor="ctr"/>
-          <a:lstStyle/>
-          <a:p>
-            <a:pPr algn="ctr" indent="0" marL="0">
-              <a:buNone/>
-            </a:pPr>
-            <a:r>
-              <a:rPr lang="en-US" sz="1300" dirty="0">
-                <a:solidFill>
-                  <a:srgbClr val="CFE7DC"/>
-                </a:solidFill>
-                <a:latin typeface="Calibri" pitchFamily="34" charset="0"/>
-                <a:ea typeface="Calibri" pitchFamily="34" charset="-122"/>
-                <a:cs typeface="Calibri" pitchFamily="34" charset="-120"/>
-              </a:rPr>
-              <a:t>Contact details here</a:t>
-            </a:r>
-            <a:endParaRPr lang="en-US" sz="1300" dirty="0"/>
-          </a:p>
-        </p:txBody>
-      </p:sp>
     </p:spTree>
   </p:cSld>
   <p:clrMapOvr>
@@ -4854,7 +5051,7 @@
                 <a:ea typeface="Calibri" pitchFamily="34" charset="-122"/>
                 <a:cs typeface="Calibri" pitchFamily="34" charset="-120"/>
               </a:rPr>
-              <a:t>Sizing must come from sources you can defend in the room.</a:t>
+              <a:t>Sized bottom-up: teachers onboarded, courses published, average sale.</a:t>
             </a:r>
             <a:endParaRPr lang="en-US" sz="1500" dirty="0"/>
           </a:p>
@@ -4869,76 +5066,15 @@
         <p:spPr>
           <a:xfrm>
             <a:off x="640080" y="1783080"/>
-            <a:ext cx="2971800" cy="310896"/>
+            <a:ext cx="3383280" cy="3566160"/>
           </a:xfrm>
           <a:prstGeom prst="roundRect">
             <a:avLst>
-              <a:gd name="adj" fmla="val 50000"/>
+              <a:gd name="adj" fmla="val 2703"/>
             </a:avLst>
           </a:prstGeom>
           <a:solidFill>
-            <a:srgbClr val="E8A33D"/>
-          </a:solidFill>
-          <a:ln/>
-        </p:spPr>
-      </p:sp>
-      <p:sp>
-        <p:nvSpPr>
-          <p:cNvPr id="5" name="Text 3"/>
-          <p:cNvSpPr txBox="1"/>
-          <p:nvPr/>
-        </p:nvSpPr>
-        <p:spPr>
-          <a:xfrm>
-            <a:off x="640080" y="1783080"/>
-            <a:ext cx="2971800" cy="310896"/>
-          </a:xfrm>
-          <a:prstGeom prst="rect">
-            <a:avLst/>
-          </a:prstGeom>
-          <a:noFill/>
-          <a:ln/>
-        </p:spPr>
-        <p:txBody>
-          <a:bodyPr wrap="square" lIns="0" tIns="0" rIns="0" bIns="0" rtlCol="0" anchor="ctr"/>
-          <a:lstStyle/>
-          <a:p>
-            <a:pPr algn="ctr" indent="0" marL="0">
-              <a:buNone/>
-            </a:pPr>
-            <a:r>
-              <a:rPr lang="en-US" sz="1050" b="1" dirty="0">
-                <a:solidFill>
-                  <a:srgbClr val="0D1B2A"/>
-                </a:solidFill>
-                <a:latin typeface="Calibri" pitchFamily="34" charset="0"/>
-                <a:ea typeface="Calibri" pitchFamily="34" charset="-122"/>
-                <a:cs typeface="Calibri" pitchFamily="34" charset="-120"/>
-              </a:rPr>
-              <a:t>YOUR NUMBERS GO HERE</a:t>
-            </a:r>
-            <a:endParaRPr lang="en-US" sz="1050" dirty="0"/>
-          </a:p>
-        </p:txBody>
-      </p:sp>
-      <p:sp>
-        <p:nvSpPr>
-          <p:cNvPr id="6" name="Shape 4"/>
-          <p:cNvSpPr/>
-          <p:nvPr/>
-        </p:nvSpPr>
-        <p:spPr>
-          <a:xfrm>
-            <a:off x="640080" y="2286000"/>
-            <a:ext cx="10881360" cy="3566160"/>
-          </a:xfrm>
-          <a:prstGeom prst="roundRect">
-            <a:avLst>
-              <a:gd name="adj" fmla="val 2564"/>
-            </a:avLst>
-          </a:prstGeom>
-          <a:solidFill>
-            <a:srgbClr val="F7F9F8"/>
+            <a:srgbClr val="E6F2ED"/>
           </a:solidFill>
           <a:ln/>
           <a:effectLst>
@@ -4952,14 +5088,92 @@
       </p:sp>
       <p:sp>
         <p:nvSpPr>
+          <p:cNvPr id="5" name="Text 3"/>
+          <p:cNvSpPr txBox="1"/>
+          <p:nvPr/>
+        </p:nvSpPr>
+        <p:spPr>
+          <a:xfrm>
+            <a:off x="960120" y="2075688"/>
+            <a:ext cx="2743200" cy="365760"/>
+          </a:xfrm>
+          <a:prstGeom prst="rect">
+            <a:avLst/>
+          </a:prstGeom>
+          <a:noFill/>
+          <a:ln/>
+        </p:spPr>
+        <p:txBody>
+          <a:bodyPr wrap="square" lIns="0" tIns="0" rIns="0" bIns="0" rtlCol="0" anchor="ctr"/>
+          <a:lstStyle/>
+          <a:p>
+            <a:pPr indent="0" marL="0">
+              <a:buNone/>
+            </a:pPr>
+            <a:r>
+              <a:rPr lang="en-US" sz="1150" b="1" spc="100" kern="0" dirty="0">
+                <a:solidFill>
+                  <a:srgbClr val="236B50"/>
+                </a:solidFill>
+                <a:latin typeface="Calibri" pitchFamily="34" charset="0"/>
+                <a:ea typeface="Calibri" pitchFamily="34" charset="-122"/>
+                <a:cs typeface="Calibri" pitchFamily="34" charset="-120"/>
+              </a:rPr>
+              <a:t>TOTAL ADDRESSABLE</a:t>
+            </a:r>
+            <a:endParaRPr lang="en-US" sz="1150" dirty="0"/>
+          </a:p>
+        </p:txBody>
+      </p:sp>
+      <p:sp>
+        <p:nvSpPr>
+          <p:cNvPr id="6" name="Text 4"/>
+          <p:cNvSpPr txBox="1"/>
+          <p:nvPr/>
+        </p:nvSpPr>
+        <p:spPr>
+          <a:xfrm>
+            <a:off x="960120" y="2514600"/>
+            <a:ext cx="2743200" cy="960120"/>
+          </a:xfrm>
+          <a:prstGeom prst="rect">
+            <a:avLst/>
+          </a:prstGeom>
+          <a:noFill/>
+          <a:ln/>
+        </p:spPr>
+        <p:txBody>
+          <a:bodyPr wrap="square" lIns="0" tIns="0" rIns="0" bIns="0" rtlCol="0" anchor="ctr"/>
+          <a:lstStyle/>
+          <a:p>
+            <a:pPr indent="0" marL="0">
+              <a:buNone/>
+            </a:pPr>
+            <a:r>
+              <a:rPr lang="en-US" sz="5400" b="1" dirty="0">
+                <a:solidFill>
+                  <a:srgbClr val="0D1B2A"/>
+                </a:solidFill>
+                <a:latin typeface="Cambria" pitchFamily="34" charset="0"/>
+                <a:ea typeface="Cambria" pitchFamily="34" charset="-122"/>
+                <a:cs typeface="Cambria" pitchFamily="34" charset="-120"/>
+              </a:rPr>
+              <a:t>—</a:t>
+            </a:r>
+            <a:endParaRPr lang="en-US" sz="5400" dirty="0"/>
+          </a:p>
+        </p:txBody>
+      </p:sp>
+      <p:sp>
+        <p:nvSpPr>
           <p:cNvPr id="7" name="Text 5"/>
           <p:cNvSpPr txBox="1"/>
           <p:nvPr/>
         </p:nvSpPr>
         <p:spPr>
           <a:xfrm>
-            <a:off x="1005840" y="2514600"/>
-            <a:ext cx="10149840" cy="365760"/>
+            <a:off x="960120" y="3611880"/>
+            <a:ext cx="2743200" cy="1463040"/>
           </a:xfrm>
           <a:prstGeom prst="rect">
             <a:avLst/>
@@ -4972,33 +5186,143 @@
           <a:lstStyle/>
           <a:p>
             <a:pPr indent="0" marL="0">
-              <a:buNone/>
-            </a:pPr>
-            <a:r>
-              <a:rPr lang="en-US" sz="1600" b="1" dirty="0">
+              <a:lnSpc>
+                <a:spcPct val="130000"/>
+              </a:lnSpc>
+              <a:buNone/>
+            </a:pPr>
+            <a:r>
+              <a:rPr lang="en-US" sz="1300" dirty="0">
+                <a:solidFill>
+                  <a:srgbClr val="6A7278"/>
+                </a:solidFill>
+                <a:latin typeface="Calibri" pitchFamily="34" charset="0"/>
+                <a:ea typeface="Calibri" pitchFamily="34" charset="-122"/>
+                <a:cs typeface="Calibri" pitchFamily="34" charset="-120"/>
+              </a:rPr>
+              <a:t>Nigerians paying for structured learning in any form today</a:t>
+            </a:r>
+            <a:endParaRPr lang="en-US" sz="1300" dirty="0"/>
+          </a:p>
+        </p:txBody>
+      </p:sp>
+      <p:sp>
+        <p:nvSpPr>
+          <p:cNvPr id="8" name="Shape 6"/>
+          <p:cNvSpPr/>
+          <p:nvPr/>
+        </p:nvSpPr>
+        <p:spPr>
+          <a:xfrm>
+            <a:off x="4343400" y="1783080"/>
+            <a:ext cx="3383280" cy="3566160"/>
+          </a:xfrm>
+          <a:prstGeom prst="roundRect">
+            <a:avLst>
+              <a:gd name="adj" fmla="val 2703"/>
+            </a:avLst>
+          </a:prstGeom>
+          <a:solidFill>
+            <a:srgbClr val="F7F9F8"/>
+          </a:solidFill>
+          <a:ln/>
+          <a:effectLst>
+            <a:outerShdw sx="100000" sy="100000" kx="0" ky="0" algn="bl" rotWithShape="0" blurRad="127000" dist="25400" dir="5400000">
+              <a:srgbClr val="000000">
+                <a:alpha val="8000"/>
+              </a:srgbClr>
+            </a:outerShdw>
+          </a:effectLst>
+        </p:spPr>
+      </p:sp>
+      <p:sp>
+        <p:nvSpPr>
+          <p:cNvPr id="9" name="Text 7"/>
+          <p:cNvSpPr txBox="1"/>
+          <p:nvPr/>
+        </p:nvSpPr>
+        <p:spPr>
+          <a:xfrm>
+            <a:off x="4663440" y="2075688"/>
+            <a:ext cx="2743200" cy="365760"/>
+          </a:xfrm>
+          <a:prstGeom prst="rect">
+            <a:avLst/>
+          </a:prstGeom>
+          <a:noFill/>
+          <a:ln/>
+        </p:spPr>
+        <p:txBody>
+          <a:bodyPr wrap="square" lIns="0" tIns="0" rIns="0" bIns="0" rtlCol="0" anchor="ctr"/>
+          <a:lstStyle/>
+          <a:p>
+            <a:pPr indent="0" marL="0">
+              <a:buNone/>
+            </a:pPr>
+            <a:r>
+              <a:rPr lang="en-US" sz="1150" b="1" spc="100" kern="0" dirty="0">
+                <a:solidFill>
+                  <a:srgbClr val="236B50"/>
+                </a:solidFill>
+                <a:latin typeface="Calibri" pitchFamily="34" charset="0"/>
+                <a:ea typeface="Calibri" pitchFamily="34" charset="-122"/>
+                <a:cs typeface="Calibri" pitchFamily="34" charset="-120"/>
+              </a:rPr>
+              <a:t>SERVICEABLE</a:t>
+            </a:r>
+            <a:endParaRPr lang="en-US" sz="1150" dirty="0"/>
+          </a:p>
+        </p:txBody>
+      </p:sp>
+      <p:sp>
+        <p:nvSpPr>
+          <p:cNvPr id="10" name="Text 8"/>
+          <p:cNvSpPr txBox="1"/>
+          <p:nvPr/>
+        </p:nvSpPr>
+        <p:spPr>
+          <a:xfrm>
+            <a:off x="4663440" y="2514600"/>
+            <a:ext cx="2743200" cy="960120"/>
+          </a:xfrm>
+          <a:prstGeom prst="rect">
+            <a:avLst/>
+          </a:prstGeom>
+          <a:noFill/>
+          <a:ln/>
+        </p:spPr>
+        <p:txBody>
+          <a:bodyPr wrap="square" lIns="0" tIns="0" rIns="0" bIns="0" rtlCol="0" anchor="ctr"/>
+          <a:lstStyle/>
+          <a:p>
+            <a:pPr indent="0" marL="0">
+              <a:buNone/>
+            </a:pPr>
+            <a:r>
+              <a:rPr lang="en-US" sz="5400" b="1" dirty="0">
                 <a:solidFill>
                   <a:srgbClr val="0D1B2A"/>
                 </a:solidFill>
-                <a:latin typeface="Calibri" pitchFamily="34" charset="0"/>
-                <a:ea typeface="Calibri" pitchFamily="34" charset="-122"/>
-                <a:cs typeface="Calibri" pitchFamily="34" charset="-120"/>
-              </a:rPr>
-              <a:t>What belongs here</a:t>
-            </a:r>
-            <a:endParaRPr lang="en-US" sz="1600" dirty="0"/>
-          </a:p>
-        </p:txBody>
-      </p:sp>
-      <p:sp>
-        <p:nvSpPr>
-          <p:cNvPr id="8" name="Text 6"/>
-          <p:cNvSpPr txBox="1"/>
-          <p:nvPr/>
-        </p:nvSpPr>
-        <p:spPr>
-          <a:xfrm>
-            <a:off x="1005840" y="2971800"/>
-            <a:ext cx="10058400" cy="2286000"/>
+                <a:latin typeface="Cambria" pitchFamily="34" charset="0"/>
+                <a:ea typeface="Cambria" pitchFamily="34" charset="-122"/>
+                <a:cs typeface="Cambria" pitchFamily="34" charset="-120"/>
+              </a:rPr>
+              <a:t>—</a:t>
+            </a:r>
+            <a:endParaRPr lang="en-US" sz="5400" dirty="0"/>
+          </a:p>
+        </p:txBody>
+      </p:sp>
+      <p:sp>
+        <p:nvSpPr>
+          <p:cNvPr id="11" name="Text 9"/>
+          <p:cNvSpPr txBox="1"/>
+          <p:nvPr/>
+        </p:nvSpPr>
+        <p:spPr>
+          <a:xfrm>
+            <a:off x="4663440" y="3611880"/>
+            <a:ext cx="2743200" cy="1463040"/>
           </a:xfrm>
           <a:prstGeom prst="rect">
             <a:avLst/>
@@ -5010,117 +5334,163 @@
           <a:bodyPr wrap="square" lIns="0" tIns="0" rIns="0" bIns="0" rtlCol="0" anchor="ctr"/>
           <a:lstStyle/>
           <a:p>
-            <a:pPr marL="342900" indent="-342900">
-              <a:spcAft>
-                <a:spcPts val="1000"/>
-              </a:spcAft>
-              <a:buSzPct val="100000"/>
-              <a:buChar char="•"/>
-            </a:pPr>
-            <a:r>
-              <a:rPr lang="en-US" sz="1350" dirty="0">
+            <a:pPr indent="0" marL="0">
+              <a:lnSpc>
+                <a:spcPct val="130000"/>
+              </a:lnSpc>
+              <a:buNone/>
+            </a:pPr>
+            <a:r>
+              <a:rPr lang="en-US" sz="1300" dirty="0">
+                <a:solidFill>
+                  <a:srgbClr val="6A7278"/>
+                </a:solidFill>
+                <a:latin typeface="Calibri" pitchFamily="34" charset="0"/>
+                <a:ea typeface="Calibri" pitchFamily="34" charset="-122"/>
+                <a:cs typeface="Calibri" pitchFamily="34" charset="-120"/>
+              </a:rPr>
+              <a:t>Smartphone users with a means of digital payment</a:t>
+            </a:r>
+            <a:endParaRPr lang="en-US" sz="1300" dirty="0"/>
+          </a:p>
+        </p:txBody>
+      </p:sp>
+      <p:sp>
+        <p:nvSpPr>
+          <p:cNvPr id="12" name="Shape 10"/>
+          <p:cNvSpPr/>
+          <p:nvPr/>
+        </p:nvSpPr>
+        <p:spPr>
+          <a:xfrm>
+            <a:off x="8046720" y="1783080"/>
+            <a:ext cx="3383280" cy="3566160"/>
+          </a:xfrm>
+          <a:prstGeom prst="roundRect">
+            <a:avLst>
+              <a:gd name="adj" fmla="val 2703"/>
+            </a:avLst>
+          </a:prstGeom>
+          <a:solidFill>
+            <a:srgbClr val="F7F9F8"/>
+          </a:solidFill>
+          <a:ln/>
+          <a:effectLst>
+            <a:outerShdw sx="100000" sy="100000" kx="0" ky="0" algn="bl" rotWithShape="0" blurRad="127000" dist="25400" dir="5400000">
+              <a:srgbClr val="000000">
+                <a:alpha val="8000"/>
+              </a:srgbClr>
+            </a:outerShdw>
+          </a:effectLst>
+        </p:spPr>
+      </p:sp>
+      <p:sp>
+        <p:nvSpPr>
+          <p:cNvPr id="13" name="Text 11"/>
+          <p:cNvSpPr txBox="1"/>
+          <p:nvPr/>
+        </p:nvSpPr>
+        <p:spPr>
+          <a:xfrm>
+            <a:off x="8366760" y="2075688"/>
+            <a:ext cx="2743200" cy="365760"/>
+          </a:xfrm>
+          <a:prstGeom prst="rect">
+            <a:avLst/>
+          </a:prstGeom>
+          <a:noFill/>
+          <a:ln/>
+        </p:spPr>
+        <p:txBody>
+          <a:bodyPr wrap="square" lIns="0" tIns="0" rIns="0" bIns="0" rtlCol="0" anchor="ctr"/>
+          <a:lstStyle/>
+          <a:p>
+            <a:pPr indent="0" marL="0">
+              <a:buNone/>
+            </a:pPr>
+            <a:r>
+              <a:rPr lang="en-US" sz="1150" b="1" spc="100" kern="0" dirty="0">
+                <a:solidFill>
+                  <a:srgbClr val="236B50"/>
+                </a:solidFill>
+                <a:latin typeface="Calibri" pitchFamily="34" charset="0"/>
+                <a:ea typeface="Calibri" pitchFamily="34" charset="-122"/>
+                <a:cs typeface="Calibri" pitchFamily="34" charset="-120"/>
+              </a:rPr>
+              <a:t>OBTAINABLE, YEAR THREE</a:t>
+            </a:r>
+            <a:endParaRPr lang="en-US" sz="1150" dirty="0"/>
+          </a:p>
+        </p:txBody>
+      </p:sp>
+      <p:sp>
+        <p:nvSpPr>
+          <p:cNvPr id="14" name="Text 12"/>
+          <p:cNvSpPr txBox="1"/>
+          <p:nvPr/>
+        </p:nvSpPr>
+        <p:spPr>
+          <a:xfrm>
+            <a:off x="8366760" y="2514600"/>
+            <a:ext cx="2743200" cy="960120"/>
+          </a:xfrm>
+          <a:prstGeom prst="rect">
+            <a:avLst/>
+          </a:prstGeom>
+          <a:noFill/>
+          <a:ln/>
+        </p:spPr>
+        <p:txBody>
+          <a:bodyPr wrap="square" lIns="0" tIns="0" rIns="0" bIns="0" rtlCol="0" anchor="ctr"/>
+          <a:lstStyle/>
+          <a:p>
+            <a:pPr indent="0" marL="0">
+              <a:buNone/>
+            </a:pPr>
+            <a:r>
+              <a:rPr lang="en-US" sz="5400" b="1" dirty="0">
                 <a:solidFill>
                   <a:srgbClr val="0D1B2A"/>
                 </a:solidFill>
-                <a:latin typeface="Calibri" pitchFamily="34" charset="0"/>
-                <a:ea typeface="Calibri" pitchFamily="34" charset="-122"/>
-                <a:cs typeface="Calibri" pitchFamily="34" charset="-120"/>
-              </a:rPr>
-              <a:t>TAM — Nigerians paying for any form of paid learning today, with the source cited</a:t>
-            </a:r>
-            <a:endParaRPr lang="en-US" sz="1350" dirty="0"/>
-          </a:p>
-          <a:p>
-            <a:pPr marL="342900" indent="-342900">
-              <a:spcAft>
-                <a:spcPts val="1000"/>
-              </a:spcAft>
-              <a:buSzPct val="100000"/>
-              <a:buChar char="•"/>
-            </a:pPr>
-            <a:r>
-              <a:rPr lang="en-US" sz="1350" dirty="0">
-                <a:solidFill>
-                  <a:srgbClr val="0D1B2A"/>
-                </a:solidFill>
-                <a:latin typeface="Calibri" pitchFamily="34" charset="0"/>
-                <a:ea typeface="Calibri" pitchFamily="34" charset="-122"/>
-                <a:cs typeface="Calibri" pitchFamily="34" charset="-120"/>
-              </a:rPr>
-              <a:t>SAM — those reachable on a smartphone with a means of digital payment</a:t>
-            </a:r>
-            <a:endParaRPr lang="en-US" sz="1350" dirty="0"/>
-          </a:p>
-          <a:p>
-            <a:pPr marL="342900" indent="-342900">
-              <a:spcAft>
-                <a:spcPts val="1000"/>
-              </a:spcAft>
-              <a:buSzPct val="100000"/>
-              <a:buChar char="•"/>
-            </a:pPr>
-            <a:r>
-              <a:rPr lang="en-US" sz="1350" dirty="0">
-                <a:solidFill>
-                  <a:srgbClr val="0D1B2A"/>
-                </a:solidFill>
-                <a:latin typeface="Calibri" pitchFamily="34" charset="0"/>
-                <a:ea typeface="Calibri" pitchFamily="34" charset="-122"/>
-                <a:cs typeface="Calibri" pitchFamily="34" charset="-120"/>
-              </a:rPr>
-              <a:t>SOM — a defensible three-year share, built bottom-up from teachers onboarded × courses × average price</a:t>
-            </a:r>
-            <a:endParaRPr lang="en-US" sz="1350" dirty="0"/>
-          </a:p>
-          <a:p>
-            <a:pPr marL="342900" indent="-342900">
-              <a:spcAft>
-                <a:spcPts val="1000"/>
-              </a:spcAft>
-              <a:buSzPct val="100000"/>
-              <a:buChar char="•"/>
-            </a:pPr>
-            <a:r>
-              <a:rPr lang="en-US" sz="1350" dirty="0">
-                <a:solidFill>
-                  <a:srgbClr val="0D1B2A"/>
-                </a:solidFill>
-                <a:latin typeface="Calibri" pitchFamily="34" charset="0"/>
-                <a:ea typeface="Calibri" pitchFamily="34" charset="-122"/>
-                <a:cs typeface="Calibri" pitchFamily="34" charset="-120"/>
-              </a:rPr>
-              <a:t>Adjacent proof points — what the market already spends on exam prep, and on informal skills training</a:t>
-            </a:r>
-            <a:endParaRPr lang="en-US" sz="1350" dirty="0"/>
-          </a:p>
-        </p:txBody>
-      </p:sp>
-      <p:sp>
-        <p:nvSpPr>
-          <p:cNvPr id="9" name="Text 7"/>
-          <p:cNvSpPr txBox="1"/>
-          <p:nvPr/>
-        </p:nvSpPr>
-        <p:spPr>
-          <a:xfrm>
-            <a:off x="640080" y="6080760"/>
-            <a:ext cx="10881360" cy="548640"/>
-          </a:xfrm>
-          <a:prstGeom prst="rect">
-            <a:avLst/>
-          </a:prstGeom>
-          <a:noFill/>
-          <a:ln/>
-        </p:spPr>
-        <p:txBody>
-          <a:bodyPr wrap="square" rtlCol="0" anchor="ctr"/>
+                <a:latin typeface="Cambria" pitchFamily="34" charset="0"/>
+                <a:ea typeface="Cambria" pitchFamily="34" charset="-122"/>
+                <a:cs typeface="Cambria" pitchFamily="34" charset="-120"/>
+              </a:rPr>
+              <a:t>—</a:t>
+            </a:r>
+            <a:endParaRPr lang="en-US" sz="5400" dirty="0"/>
+          </a:p>
+        </p:txBody>
+      </p:sp>
+      <p:sp>
+        <p:nvSpPr>
+          <p:cNvPr id="15" name="Text 13"/>
+          <p:cNvSpPr txBox="1"/>
+          <p:nvPr/>
+        </p:nvSpPr>
+        <p:spPr>
+          <a:xfrm>
+            <a:off x="8366760" y="3611880"/>
+            <a:ext cx="2743200" cy="1463040"/>
+          </a:xfrm>
+          <a:prstGeom prst="rect">
+            <a:avLst/>
+          </a:prstGeom>
+          <a:noFill/>
+          <a:ln/>
+        </p:spPr>
+        <p:txBody>
+          <a:bodyPr wrap="square" lIns="0" tIns="0" rIns="0" bIns="0" rtlCol="0" anchor="ctr"/>
           <a:lstStyle/>
           <a:p>
             <a:pPr indent="0" marL="0">
-              <a:buNone/>
-            </a:pPr>
-            <a:r>
-              <a:rPr lang="en-US" sz="1300" i="1" dirty="0">
+              <a:lnSpc>
+                <a:spcPct val="130000"/>
+              </a:lnSpc>
+              <a:buNone/>
+            </a:pPr>
+            <a:r>
+              <a:rPr lang="en-US" sz="1300" dirty="0">
                 <a:solidFill>
                   <a:srgbClr val="6A7278"/>
                 </a:solidFill>
@@ -5128,7 +5498,7 @@
                 <a:ea typeface="Calibri" pitchFamily="34" charset="-122"/>
                 <a:cs typeface="Calibri" pitchFamily="34" charset="-120"/>
               </a:rPr>
-              <a:t>Build the bottom-up number first and lead with it. A large top-down TAM invites scepticism; a defensible bottom-up model invites the next question.</a:t>
+              <a:t>Teachers onboarded x courses published x average sale value</a:t>
             </a:r>
             <a:endParaRPr lang="en-US" sz="1300" dirty="0"/>
           </a:p>
@@ -5688,7 +6058,7 @@
                 <a:ea typeface="Calibri" pitchFamily="34" charset="-122"/>
                 <a:cs typeface="Calibri" pitchFamily="34" charset="-120"/>
               </a:rPr>
-              <a:t>Later lines — promoted placement, cohort courses, certification — are deliberately not in this model.</a:t>
+              <a:t>Promoted placement, cohort courses and certification are potential future lines, and are excluded from these figures.</a:t>
             </a:r>
             <a:endParaRPr lang="en-US" sz="1300" dirty="0"/>
           </a:p>
@@ -5791,7 +6161,7 @@
                 <a:ea typeface="Calibri" pitchFamily="34" charset="-122"/>
                 <a:cs typeface="Calibri" pitchFamily="34" charset="-120"/>
               </a:rPr>
-              <a:t>The revenue side is known. The cost side is yours to fill.</a:t>
+              <a:t>Revenue per sale is fixed by the model. Acquisition is the variable.</a:t>
             </a:r>
             <a:endParaRPr lang="en-US" sz="1500" dirty="0"/>
           </a:p>
@@ -5851,7 +6221,7 @@
               <a:buNone/>
             </a:pPr>
             <a:r>
-              <a:rPr lang="en-US" sz="1600" b="1" dirty="0">
+              <a:rPr lang="en-US" sz="1700" b="1" dirty="0">
                 <a:solidFill>
                   <a:srgbClr val="236B50"/>
                 </a:solidFill>
@@ -5859,9 +6229,9 @@
                 <a:ea typeface="Calibri" pitchFamily="34" charset="-122"/>
                 <a:cs typeface="Calibri" pitchFamily="34" charset="-120"/>
               </a:rPr>
-              <a:t>Known</a:t>
-            </a:r>
-            <a:endParaRPr lang="en-US" sz="1600" dirty="0"/>
+              <a:t>Per sale</a:t>
+            </a:r>
+            <a:endParaRPr lang="en-US" sz="1700" dirty="0"/>
           </a:p>
         </p:txBody>
       </p:sp>
@@ -5873,8 +6243,8 @@
         </p:nvSpPr>
         <p:spPr>
           <a:xfrm>
-            <a:off x="1005840" y="2560320"/>
-            <a:ext cx="4572000" cy="2560320"/>
+            <a:off x="1005840" y="2606040"/>
+            <a:ext cx="4572000" cy="2926080"/>
           </a:xfrm>
           <a:prstGeom prst="rect">
             <a:avLst/>
@@ -5888,13 +6258,13 @@
           <a:p>
             <a:pPr marL="342900" indent="-342900">
               <a:spcAft>
-                <a:spcPts val="800"/>
+                <a:spcPts val="1000"/>
               </a:spcAft>
               <a:buSzPct val="100000"/>
               <a:buChar char="•"/>
             </a:pPr>
             <a:r>
-              <a:rPr lang="en-US" sz="1300" dirty="0">
+              <a:rPr lang="en-US" sz="1350" dirty="0">
                 <a:solidFill>
                   <a:srgbClr val="0D1B2A"/>
                 </a:solidFill>
@@ -5902,20 +6272,20 @@
                 <a:ea typeface="Calibri" pitchFamily="34" charset="-122"/>
                 <a:cs typeface="Calibri" pitchFamily="34" charset="-120"/>
               </a:rPr>
-              <a:t>Revenue per sale: 15% of settled amount</a:t>
-            </a:r>
-            <a:endParaRPr lang="en-US" sz="1300" dirty="0"/>
+              <a:t>Revenue: 15% of the settled amount</a:t>
+            </a:r>
+            <a:endParaRPr lang="en-US" sz="1350" dirty="0"/>
           </a:p>
           <a:p>
             <a:pPr marL="342900" indent="-342900">
               <a:spcAft>
-                <a:spcPts val="800"/>
+                <a:spcPts val="1000"/>
               </a:spcAft>
               <a:buSzPct val="100000"/>
               <a:buChar char="•"/>
             </a:pPr>
             <a:r>
-              <a:rPr lang="en-US" sz="1300" dirty="0">
+              <a:rPr lang="en-US" sz="1350" dirty="0">
                 <a:solidFill>
                   <a:srgbClr val="0D1B2A"/>
                 </a:solidFill>
@@ -5923,20 +6293,20 @@
                 <a:ea typeface="Calibri" pitchFamily="34" charset="-122"/>
                 <a:cs typeface="Calibri" pitchFamily="34" charset="-120"/>
               </a:rPr>
-              <a:t>Processing: 1.5%, plus ₦100 above ₦2,500, capped at ₦2,000</a:t>
-            </a:r>
-            <a:endParaRPr lang="en-US" sz="1300" dirty="0"/>
+              <a:t>Processing: 1.5%, plus N100 above N2,500, capped at N2,000</a:t>
+            </a:r>
+            <a:endParaRPr lang="en-US" sz="1350" dirty="0"/>
           </a:p>
           <a:p>
             <a:pPr marL="342900" indent="-342900">
               <a:spcAft>
-                <a:spcPts val="800"/>
+                <a:spcPts val="1000"/>
               </a:spcAft>
               <a:buSzPct val="100000"/>
               <a:buChar char="•"/>
             </a:pPr>
             <a:r>
-              <a:rPr lang="en-US" sz="1300" dirty="0">
+              <a:rPr lang="en-US" sz="1350" dirty="0">
                 <a:solidFill>
                   <a:srgbClr val="0D1B2A"/>
                 </a:solidFill>
@@ -5944,20 +6314,20 @@
                 <a:ea typeface="Calibri" pitchFamily="34" charset="-122"/>
                 <a:cs typeface="Calibri" pitchFamily="34" charset="-120"/>
               </a:rPr>
-              <a:t>Marginal hosting cost per enrolment is close to zero</a:t>
-            </a:r>
-            <a:endParaRPr lang="en-US" sz="1300" dirty="0"/>
+              <a:t>Marginal hosting cost per enrolment near zero</a:t>
+            </a:r>
+            <a:endParaRPr lang="en-US" sz="1350" dirty="0"/>
           </a:p>
           <a:p>
             <a:pPr marL="342900" indent="-342900">
               <a:spcAft>
-                <a:spcPts val="800"/>
+                <a:spcPts val="1000"/>
               </a:spcAft>
               <a:buSzPct val="100000"/>
               <a:buChar char="•"/>
             </a:pPr>
             <a:r>
-              <a:rPr lang="en-US" sz="1300" dirty="0">
+              <a:rPr lang="en-US" sz="1350" dirty="0">
                 <a:solidFill>
                   <a:srgbClr val="0D1B2A"/>
                 </a:solidFill>
@@ -5967,7 +6337,7 @@
               </a:rPr>
               <a:t>No cost of goods — teachers supply the content</a:t>
             </a:r>
-            <a:endParaRPr lang="en-US" sz="1300" dirty="0"/>
+            <a:endParaRPr lang="en-US" sz="1350" dirty="0"/>
           </a:p>
         </p:txBody>
       </p:sp>
@@ -6002,25 +6372,42 @@
       </p:sp>
       <p:sp>
         <p:nvSpPr>
-          <p:cNvPr id="8" name="Shape 6"/>
-          <p:cNvSpPr/>
-          <p:nvPr/>
-        </p:nvSpPr>
-        <p:spPr>
-          <a:xfrm>
-            <a:off x="6583680" y="2039112"/>
-            <a:ext cx="2971800" cy="310896"/>
-          </a:xfrm>
-          <a:prstGeom prst="roundRect">
-            <a:avLst>
-              <a:gd name="adj" fmla="val 50000"/>
-            </a:avLst>
-          </a:prstGeom>
-          <a:solidFill>
-            <a:srgbClr val="E8A33D"/>
-          </a:solidFill>
-          <a:ln/>
-        </p:spPr>
+          <p:cNvPr id="8" name="Text 6"/>
+          <p:cNvSpPr txBox="1"/>
+          <p:nvPr/>
+        </p:nvSpPr>
+        <p:spPr>
+          <a:xfrm>
+            <a:off x="6583680" y="2057400"/>
+            <a:ext cx="4572000" cy="365760"/>
+          </a:xfrm>
+          <a:prstGeom prst="rect">
+            <a:avLst/>
+          </a:prstGeom>
+          <a:noFill/>
+          <a:ln/>
+        </p:spPr>
+        <p:txBody>
+          <a:bodyPr wrap="square" lIns="0" tIns="0" rIns="0" bIns="0" rtlCol="0" anchor="ctr"/>
+          <a:lstStyle/>
+          <a:p>
+            <a:pPr indent="0" marL="0">
+              <a:buNone/>
+            </a:pPr>
+            <a:r>
+              <a:rPr lang="en-US" sz="1700" b="1" dirty="0">
+                <a:solidFill>
+                  <a:srgbClr val="0D1B2A"/>
+                </a:solidFill>
+                <a:latin typeface="Calibri" pitchFamily="34" charset="0"/>
+                <a:ea typeface="Calibri" pitchFamily="34" charset="-122"/>
+                <a:cs typeface="Calibri" pitchFamily="34" charset="-120"/>
+              </a:rPr>
+              <a:t>Per customer</a:t>
+            </a:r>
+            <a:endParaRPr lang="en-US" sz="1700" dirty="0"/>
+          </a:p>
+        </p:txBody>
       </p:sp>
       <p:sp>
         <p:nvSpPr>
@@ -6030,8 +6417,8 @@
         </p:nvSpPr>
         <p:spPr>
           <a:xfrm>
-            <a:off x="6583680" y="2039112"/>
-            <a:ext cx="2971800" cy="310896"/>
+            <a:off x="6583680" y="2651760"/>
+            <a:ext cx="3383280" cy="365760"/>
           </a:xfrm>
           <a:prstGeom prst="rect">
             <a:avLst/>
@@ -6043,11 +6430,50 @@
           <a:bodyPr wrap="square" lIns="0" tIns="0" rIns="0" bIns="0" rtlCol="0" anchor="ctr"/>
           <a:lstStyle/>
           <a:p>
-            <a:pPr algn="ctr" indent="0" marL="0">
-              <a:buNone/>
-            </a:pPr>
-            <a:r>
-              <a:rPr lang="en-US" sz="1050" b="1" dirty="0">
+            <a:pPr indent="0" marL="0">
+              <a:buNone/>
+            </a:pPr>
+            <a:r>
+              <a:rPr lang="en-US" sz="1350" dirty="0">
+                <a:solidFill>
+                  <a:srgbClr val="6A7278"/>
+                </a:solidFill>
+                <a:latin typeface="Calibri" pitchFamily="34" charset="0"/>
+                <a:ea typeface="Calibri" pitchFamily="34" charset="-122"/>
+                <a:cs typeface="Calibri" pitchFamily="34" charset="-120"/>
+              </a:rPr>
+              <a:t>Acquisition cost, learner</a:t>
+            </a:r>
+            <a:endParaRPr lang="en-US" sz="1350" dirty="0"/>
+          </a:p>
+        </p:txBody>
+      </p:sp>
+      <p:sp>
+        <p:nvSpPr>
+          <p:cNvPr id="10" name="Text 8"/>
+          <p:cNvSpPr txBox="1"/>
+          <p:nvPr/>
+        </p:nvSpPr>
+        <p:spPr>
+          <a:xfrm>
+            <a:off x="9966960" y="2651760"/>
+            <a:ext cx="1188720" cy="365760"/>
+          </a:xfrm>
+          <a:prstGeom prst="rect">
+            <a:avLst/>
+          </a:prstGeom>
+          <a:noFill/>
+          <a:ln/>
+        </p:spPr>
+        <p:txBody>
+          <a:bodyPr wrap="square" lIns="0" tIns="0" rIns="0" bIns="0" rtlCol="0" anchor="ctr"/>
+          <a:lstStyle/>
+          <a:p>
+            <a:pPr algn="r" indent="0" marL="0">
+              <a:buNone/>
+            </a:pPr>
+            <a:r>
+              <a:rPr lang="en-US" sz="1500" b="1" dirty="0">
                 <a:solidFill>
                   <a:srgbClr val="0D1B2A"/>
                 </a:solidFill>
@@ -6055,22 +6481,22 @@
                 <a:ea typeface="Calibri" pitchFamily="34" charset="-122"/>
                 <a:cs typeface="Calibri" pitchFamily="34" charset="-120"/>
               </a:rPr>
-              <a:t>YOUR NUMBERS GO HERE</a:t>
-            </a:r>
-            <a:endParaRPr lang="en-US" sz="1050" dirty="0"/>
-          </a:p>
-        </p:txBody>
-      </p:sp>
-      <p:sp>
-        <p:nvSpPr>
-          <p:cNvPr id="10" name="Text 8"/>
-          <p:cNvSpPr txBox="1"/>
-          <p:nvPr/>
-        </p:nvSpPr>
-        <p:spPr>
-          <a:xfrm>
-            <a:off x="6583680" y="2560320"/>
-            <a:ext cx="4572000" cy="2560320"/>
+              <a:t>—</a:t>
+            </a:r>
+            <a:endParaRPr lang="en-US" sz="1500" dirty="0"/>
+          </a:p>
+        </p:txBody>
+      </p:sp>
+      <p:sp>
+        <p:nvSpPr>
+          <p:cNvPr id="11" name="Text 9"/>
+          <p:cNvSpPr txBox="1"/>
+          <p:nvPr/>
+        </p:nvSpPr>
+        <p:spPr>
+          <a:xfrm>
+            <a:off x="6583680" y="3236976"/>
+            <a:ext cx="3383280" cy="365760"/>
           </a:xfrm>
           <a:prstGeom prst="rect">
             <a:avLst/>
@@ -6082,15 +6508,50 @@
           <a:bodyPr wrap="square" lIns="0" tIns="0" rIns="0" bIns="0" rtlCol="0" anchor="ctr"/>
           <a:lstStyle/>
           <a:p>
-            <a:pPr marL="342900" indent="-342900">
-              <a:spcAft>
-                <a:spcPts val="800"/>
-              </a:spcAft>
-              <a:buSzPct val="100000"/>
-              <a:buChar char="•"/>
-            </a:pPr>
-            <a:r>
-              <a:rPr lang="en-US" sz="1300" dirty="0">
+            <a:pPr indent="0" marL="0">
+              <a:buNone/>
+            </a:pPr>
+            <a:r>
+              <a:rPr lang="en-US" sz="1350" dirty="0">
+                <a:solidFill>
+                  <a:srgbClr val="6A7278"/>
+                </a:solidFill>
+                <a:latin typeface="Calibri" pitchFamily="34" charset="0"/>
+                <a:ea typeface="Calibri" pitchFamily="34" charset="-122"/>
+                <a:cs typeface="Calibri" pitchFamily="34" charset="-120"/>
+              </a:rPr>
+              <a:t>Acquisition cost, teacher</a:t>
+            </a:r>
+            <a:endParaRPr lang="en-US" sz="1350" dirty="0"/>
+          </a:p>
+        </p:txBody>
+      </p:sp>
+      <p:sp>
+        <p:nvSpPr>
+          <p:cNvPr id="12" name="Text 10"/>
+          <p:cNvSpPr txBox="1"/>
+          <p:nvPr/>
+        </p:nvSpPr>
+        <p:spPr>
+          <a:xfrm>
+            <a:off x="9966960" y="3236976"/>
+            <a:ext cx="1188720" cy="365760"/>
+          </a:xfrm>
+          <a:prstGeom prst="rect">
+            <a:avLst/>
+          </a:prstGeom>
+          <a:noFill/>
+          <a:ln/>
+        </p:spPr>
+        <p:txBody>
+          <a:bodyPr wrap="square" lIns="0" tIns="0" rIns="0" bIns="0" rtlCol="0" anchor="ctr"/>
+          <a:lstStyle/>
+          <a:p>
+            <a:pPr algn="r" indent="0" marL="0">
+              <a:buNone/>
+            </a:pPr>
+            <a:r>
+              <a:rPr lang="en-US" sz="1500" b="1" dirty="0">
                 <a:solidFill>
                   <a:srgbClr val="0D1B2A"/>
                 </a:solidFill>
@@ -6098,20 +6559,77 @@
                 <a:ea typeface="Calibri" pitchFamily="34" charset="-122"/>
                 <a:cs typeface="Calibri" pitchFamily="34" charset="-120"/>
               </a:rPr>
-              <a:t>CAC — per learner and per teacher, which will differ sharply</a:t>
-            </a:r>
-            <a:endParaRPr lang="en-US" sz="1300" dirty="0"/>
-          </a:p>
-          <a:p>
-            <a:pPr marL="342900" indent="-342900">
-              <a:spcAft>
-                <a:spcPts val="800"/>
-              </a:spcAft>
-              <a:buSzPct val="100000"/>
-              <a:buChar char="•"/>
-            </a:pPr>
-            <a:r>
-              <a:rPr lang="en-US" sz="1300" dirty="0">
+              <a:t>—</a:t>
+            </a:r>
+            <a:endParaRPr lang="en-US" sz="1500" dirty="0"/>
+          </a:p>
+        </p:txBody>
+      </p:sp>
+      <p:sp>
+        <p:nvSpPr>
+          <p:cNvPr id="13" name="Text 11"/>
+          <p:cNvSpPr txBox="1"/>
+          <p:nvPr/>
+        </p:nvSpPr>
+        <p:spPr>
+          <a:xfrm>
+            <a:off x="6583680" y="3822192"/>
+            <a:ext cx="3383280" cy="365760"/>
+          </a:xfrm>
+          <a:prstGeom prst="rect">
+            <a:avLst/>
+          </a:prstGeom>
+          <a:noFill/>
+          <a:ln/>
+        </p:spPr>
+        <p:txBody>
+          <a:bodyPr wrap="square" lIns="0" tIns="0" rIns="0" bIns="0" rtlCol="0" anchor="ctr"/>
+          <a:lstStyle/>
+          <a:p>
+            <a:pPr indent="0" marL="0">
+              <a:buNone/>
+            </a:pPr>
+            <a:r>
+              <a:rPr lang="en-US" sz="1350" dirty="0">
+                <a:solidFill>
+                  <a:srgbClr val="6A7278"/>
+                </a:solidFill>
+                <a:latin typeface="Calibri" pitchFamily="34" charset="0"/>
+                <a:ea typeface="Calibri" pitchFamily="34" charset="-122"/>
+                <a:cs typeface="Calibri" pitchFamily="34" charset="-120"/>
+              </a:rPr>
+              <a:t>Average order value</a:t>
+            </a:r>
+            <a:endParaRPr lang="en-US" sz="1350" dirty="0"/>
+          </a:p>
+        </p:txBody>
+      </p:sp>
+      <p:sp>
+        <p:nvSpPr>
+          <p:cNvPr id="14" name="Text 12"/>
+          <p:cNvSpPr txBox="1"/>
+          <p:nvPr/>
+        </p:nvSpPr>
+        <p:spPr>
+          <a:xfrm>
+            <a:off x="9966960" y="3822192"/>
+            <a:ext cx="1188720" cy="365760"/>
+          </a:xfrm>
+          <a:prstGeom prst="rect">
+            <a:avLst/>
+          </a:prstGeom>
+          <a:noFill/>
+          <a:ln/>
+        </p:spPr>
+        <p:txBody>
+          <a:bodyPr wrap="square" lIns="0" tIns="0" rIns="0" bIns="0" rtlCol="0" anchor="ctr"/>
+          <a:lstStyle/>
+          <a:p>
+            <a:pPr algn="r" indent="0" marL="0">
+              <a:buNone/>
+            </a:pPr>
+            <a:r>
+              <a:rPr lang="en-US" sz="1500" b="1" dirty="0">
                 <a:solidFill>
                   <a:srgbClr val="0D1B2A"/>
                 </a:solidFill>
@@ -6119,20 +6637,77 @@
                 <a:ea typeface="Calibri" pitchFamily="34" charset="-122"/>
                 <a:cs typeface="Calibri" pitchFamily="34" charset="-120"/>
               </a:rPr>
-              <a:t>Average order value, and repeat purchase rate</a:t>
-            </a:r>
-            <a:endParaRPr lang="en-US" sz="1300" dirty="0"/>
-          </a:p>
-          <a:p>
-            <a:pPr marL="342900" indent="-342900">
-              <a:spcAft>
-                <a:spcPts val="800"/>
-              </a:spcAft>
-              <a:buSzPct val="100000"/>
-              <a:buChar char="•"/>
-            </a:pPr>
-            <a:r>
-              <a:rPr lang="en-US" sz="1300" dirty="0">
+              <a:t>—</a:t>
+            </a:r>
+            <a:endParaRPr lang="en-US" sz="1500" dirty="0"/>
+          </a:p>
+        </p:txBody>
+      </p:sp>
+      <p:sp>
+        <p:nvSpPr>
+          <p:cNvPr id="15" name="Text 13"/>
+          <p:cNvSpPr txBox="1"/>
+          <p:nvPr/>
+        </p:nvSpPr>
+        <p:spPr>
+          <a:xfrm>
+            <a:off x="6583680" y="4407408"/>
+            <a:ext cx="3383280" cy="365760"/>
+          </a:xfrm>
+          <a:prstGeom prst="rect">
+            <a:avLst/>
+          </a:prstGeom>
+          <a:noFill/>
+          <a:ln/>
+        </p:spPr>
+        <p:txBody>
+          <a:bodyPr wrap="square" lIns="0" tIns="0" rIns="0" bIns="0" rtlCol="0" anchor="ctr"/>
+          <a:lstStyle/>
+          <a:p>
+            <a:pPr indent="0" marL="0">
+              <a:buNone/>
+            </a:pPr>
+            <a:r>
+              <a:rPr lang="en-US" sz="1350" dirty="0">
+                <a:solidFill>
+                  <a:srgbClr val="6A7278"/>
+                </a:solidFill>
+                <a:latin typeface="Calibri" pitchFamily="34" charset="0"/>
+                <a:ea typeface="Calibri" pitchFamily="34" charset="-122"/>
+                <a:cs typeface="Calibri" pitchFamily="34" charset="-120"/>
+              </a:rPr>
+              <a:t>Repeat purchase rate</a:t>
+            </a:r>
+            <a:endParaRPr lang="en-US" sz="1350" dirty="0"/>
+          </a:p>
+        </p:txBody>
+      </p:sp>
+      <p:sp>
+        <p:nvSpPr>
+          <p:cNvPr id="16" name="Text 14"/>
+          <p:cNvSpPr txBox="1"/>
+          <p:nvPr/>
+        </p:nvSpPr>
+        <p:spPr>
+          <a:xfrm>
+            <a:off x="9966960" y="4407408"/>
+            <a:ext cx="1188720" cy="365760"/>
+          </a:xfrm>
+          <a:prstGeom prst="rect">
+            <a:avLst/>
+          </a:prstGeom>
+          <a:noFill/>
+          <a:ln/>
+        </p:spPr>
+        <p:txBody>
+          <a:bodyPr wrap="square" lIns="0" tIns="0" rIns="0" bIns="0" rtlCol="0" anchor="ctr"/>
+          <a:lstStyle/>
+          <a:p>
+            <a:pPr algn="r" indent="0" marL="0">
+              <a:buNone/>
+            </a:pPr>
+            <a:r>
+              <a:rPr lang="en-US" sz="1500" b="1" dirty="0">
                 <a:solidFill>
                   <a:srgbClr val="0D1B2A"/>
                 </a:solidFill>
@@ -6140,20 +6715,77 @@
                 <a:ea typeface="Calibri" pitchFamily="34" charset="-122"/>
                 <a:cs typeface="Calibri" pitchFamily="34" charset="-120"/>
               </a:rPr>
-              <a:t>Teacher retention — how many publish a second course</a:t>
-            </a:r>
-            <a:endParaRPr lang="en-US" sz="1300" dirty="0"/>
-          </a:p>
-          <a:p>
-            <a:pPr marL="342900" indent="-342900">
-              <a:spcAft>
-                <a:spcPts val="800"/>
-              </a:spcAft>
-              <a:buSzPct val="100000"/>
-              <a:buChar char="•"/>
-            </a:pPr>
-            <a:r>
-              <a:rPr lang="en-US" sz="1300" dirty="0">
+              <a:t>—</a:t>
+            </a:r>
+            <a:endParaRPr lang="en-US" sz="1500" dirty="0"/>
+          </a:p>
+        </p:txBody>
+      </p:sp>
+      <p:sp>
+        <p:nvSpPr>
+          <p:cNvPr id="17" name="Text 15"/>
+          <p:cNvSpPr txBox="1"/>
+          <p:nvPr/>
+        </p:nvSpPr>
+        <p:spPr>
+          <a:xfrm>
+            <a:off x="6583680" y="4992624"/>
+            <a:ext cx="3383280" cy="365760"/>
+          </a:xfrm>
+          <a:prstGeom prst="rect">
+            <a:avLst/>
+          </a:prstGeom>
+          <a:noFill/>
+          <a:ln/>
+        </p:spPr>
+        <p:txBody>
+          <a:bodyPr wrap="square" lIns="0" tIns="0" rIns="0" bIns="0" rtlCol="0" anchor="ctr"/>
+          <a:lstStyle/>
+          <a:p>
+            <a:pPr indent="0" marL="0">
+              <a:buNone/>
+            </a:pPr>
+            <a:r>
+              <a:rPr lang="en-US" sz="1350" dirty="0">
+                <a:solidFill>
+                  <a:srgbClr val="6A7278"/>
+                </a:solidFill>
+                <a:latin typeface="Calibri" pitchFamily="34" charset="0"/>
+                <a:ea typeface="Calibri" pitchFamily="34" charset="-122"/>
+                <a:cs typeface="Calibri" pitchFamily="34" charset="-120"/>
+              </a:rPr>
+              <a:t>LTV to CAC</a:t>
+            </a:r>
+            <a:endParaRPr lang="en-US" sz="1350" dirty="0"/>
+          </a:p>
+        </p:txBody>
+      </p:sp>
+      <p:sp>
+        <p:nvSpPr>
+          <p:cNvPr id="18" name="Text 16"/>
+          <p:cNvSpPr txBox="1"/>
+          <p:nvPr/>
+        </p:nvSpPr>
+        <p:spPr>
+          <a:xfrm>
+            <a:off x="9966960" y="4992624"/>
+            <a:ext cx="1188720" cy="365760"/>
+          </a:xfrm>
+          <a:prstGeom prst="rect">
+            <a:avLst/>
+          </a:prstGeom>
+          <a:noFill/>
+          <a:ln/>
+        </p:spPr>
+        <p:txBody>
+          <a:bodyPr wrap="square" lIns="0" tIns="0" rIns="0" bIns="0" rtlCol="0" anchor="ctr"/>
+          <a:lstStyle/>
+          <a:p>
+            <a:pPr algn="r" indent="0" marL="0">
+              <a:buNone/>
+            </a:pPr>
+            <a:r>
+              <a:rPr lang="en-US" sz="1500" b="1" dirty="0">
                 <a:solidFill>
                   <a:srgbClr val="0D1B2A"/>
                 </a:solidFill>
@@ -6161,48 +6793,9 @@
                 <a:ea typeface="Calibri" pitchFamily="34" charset="-122"/>
                 <a:cs typeface="Calibri" pitchFamily="34" charset="-120"/>
               </a:rPr>
-              <a:t>Payback period, and LTV/CAC</a:t>
-            </a:r>
-            <a:endParaRPr lang="en-US" sz="1300" dirty="0"/>
-          </a:p>
-        </p:txBody>
-      </p:sp>
-      <p:sp>
-        <p:nvSpPr>
-          <p:cNvPr id="11" name="Text 9"/>
-          <p:cNvSpPr txBox="1"/>
-          <p:nvPr/>
-        </p:nvSpPr>
-        <p:spPr>
-          <a:xfrm>
-            <a:off x="640080" y="5989320"/>
-            <a:ext cx="10881360" cy="640080"/>
-          </a:xfrm>
-          <a:prstGeom prst="rect">
-            <a:avLst/>
-          </a:prstGeom>
-          <a:noFill/>
-          <a:ln/>
-        </p:spPr>
-        <p:txBody>
-          <a:bodyPr wrap="square" rtlCol="0" anchor="ctr"/>
-          <a:lstStyle/>
-          <a:p>
-            <a:pPr indent="0" marL="0">
-              <a:buNone/>
-            </a:pPr>
-            <a:r>
-              <a:rPr lang="en-US" sz="1300" i="1" dirty="0">
-                <a:solidFill>
-                  <a:srgbClr val="6A7278"/>
-                </a:solidFill>
-                <a:latin typeface="Calibri" pitchFamily="34" charset="0"/>
-                <a:ea typeface="Calibri" pitchFamily="34" charset="-122"/>
-                <a:cs typeface="Calibri" pitchFamily="34" charset="-120"/>
-              </a:rPr>
-              <a:t>Teacher acquisition is the number that decides this business. One teacher who brings their own students is worth many paid learner installs — if that holds, say so with evidence.</a:t>
-            </a:r>
-            <a:endParaRPr lang="en-US" sz="1300" dirty="0"/>
+              <a:t>—</a:t>
+            </a:r>
+            <a:endParaRPr lang="en-US" sz="1500" dirty="0"/>
           </a:p>
         </p:txBody>
       </p:sp>
@@ -6966,7 +7559,7 @@
                 <a:ea typeface="Calibri" pitchFamily="34" charset="-122"/>
                 <a:cs typeface="Calibri" pitchFamily="34" charset="-120"/>
               </a:rPr>
-              <a:t>Currently pre-launch. This slide is the one investors read first.</a:t>
+              <a:t>Pre-launch. Product built end to end; first cohort in preparation.</a:t>
             </a:r>
             <a:endParaRPr lang="en-US" sz="1500" dirty="0"/>
           </a:p>
@@ -6981,76 +7574,15 @@
         <p:spPr>
           <a:xfrm>
             <a:off x="640080" y="1783080"/>
-            <a:ext cx="2971800" cy="310896"/>
+            <a:ext cx="2514600" cy="2286000"/>
           </a:xfrm>
           <a:prstGeom prst="roundRect">
             <a:avLst>
-              <a:gd name="adj" fmla="val 50000"/>
+              <a:gd name="adj" fmla="val 4000"/>
             </a:avLst>
           </a:prstGeom>
           <a:solidFill>
-            <a:srgbClr val="E8A33D"/>
-          </a:solidFill>
-          <a:ln/>
-        </p:spPr>
-      </p:sp>
-      <p:sp>
-        <p:nvSpPr>
-          <p:cNvPr id="5" name="Text 3"/>
-          <p:cNvSpPr txBox="1"/>
-          <p:nvPr/>
-        </p:nvSpPr>
-        <p:spPr>
-          <a:xfrm>
-            <a:off x="640080" y="1783080"/>
-            <a:ext cx="2971800" cy="310896"/>
-          </a:xfrm>
-          <a:prstGeom prst="rect">
-            <a:avLst/>
-          </a:prstGeom>
-          <a:noFill/>
-          <a:ln/>
-        </p:spPr>
-        <p:txBody>
-          <a:bodyPr wrap="square" lIns="0" tIns="0" rIns="0" bIns="0" rtlCol="0" anchor="ctr"/>
-          <a:lstStyle/>
-          <a:p>
-            <a:pPr algn="ctr" indent="0" marL="0">
-              <a:buNone/>
-            </a:pPr>
-            <a:r>
-              <a:rPr lang="en-US" sz="1050" b="1" dirty="0">
-                <a:solidFill>
-                  <a:srgbClr val="0D1B2A"/>
-                </a:solidFill>
-                <a:latin typeface="Calibri" pitchFamily="34" charset="0"/>
-                <a:ea typeface="Calibri" pitchFamily="34" charset="-122"/>
-                <a:cs typeface="Calibri" pitchFamily="34" charset="-120"/>
-              </a:rPr>
-              <a:t>YOUR NUMBERS GO HERE</a:t>
-            </a:r>
-            <a:endParaRPr lang="en-US" sz="1050" dirty="0"/>
-          </a:p>
-        </p:txBody>
-      </p:sp>
-      <p:sp>
-        <p:nvSpPr>
-          <p:cNvPr id="6" name="Shape 4"/>
-          <p:cNvSpPr/>
-          <p:nvPr/>
-        </p:nvSpPr>
-        <p:spPr>
-          <a:xfrm>
-            <a:off x="640080" y="2286000"/>
-            <a:ext cx="10881360" cy="3383280"/>
-          </a:xfrm>
-          <a:prstGeom prst="roundRect">
-            <a:avLst>
-              <a:gd name="adj" fmla="val 2703"/>
-            </a:avLst>
-          </a:prstGeom>
-          <a:solidFill>
-            <a:srgbClr val="F7F9F8"/>
+            <a:srgbClr val="E6F2ED"/>
           </a:solidFill>
           <a:ln/>
           <a:effectLst>
@@ -7064,13 +7596,453 @@
       </p:sp>
       <p:sp>
         <p:nvSpPr>
-          <p:cNvPr id="7" name="Text 5"/>
-          <p:cNvSpPr txBox="1"/>
-          <p:nvPr/>
-        </p:nvSpPr>
-        <p:spPr>
-          <a:xfrm>
-            <a:off x="1005840" y="2514600"/>
+          <p:cNvPr id="5" name="Text 3"/>
+          <p:cNvSpPr txBox="1"/>
+          <p:nvPr/>
+        </p:nvSpPr>
+        <p:spPr>
+          <a:xfrm>
+            <a:off x="914400" y="2167128"/>
+            <a:ext cx="1965960" cy="914400"/>
+          </a:xfrm>
+          <a:prstGeom prst="rect">
+            <a:avLst/>
+          </a:prstGeom>
+          <a:noFill/>
+          <a:ln/>
+        </p:spPr>
+        <p:txBody>
+          <a:bodyPr wrap="square" lIns="0" tIns="0" rIns="0" bIns="0" rtlCol="0" anchor="ctr"/>
+          <a:lstStyle/>
+          <a:p>
+            <a:pPr indent="0" marL="0">
+              <a:buNone/>
+            </a:pPr>
+            <a:r>
+              <a:rPr lang="en-US" sz="4800" b="1" dirty="0">
+                <a:solidFill>
+                  <a:srgbClr val="0D1B2A"/>
+                </a:solidFill>
+                <a:latin typeface="Cambria" pitchFamily="34" charset="0"/>
+                <a:ea typeface="Cambria" pitchFamily="34" charset="-122"/>
+                <a:cs typeface="Cambria" pitchFamily="34" charset="-120"/>
+              </a:rPr>
+              <a:t>—</a:t>
+            </a:r>
+            <a:endParaRPr lang="en-US" sz="4800" dirty="0"/>
+          </a:p>
+        </p:txBody>
+      </p:sp>
+      <p:sp>
+        <p:nvSpPr>
+          <p:cNvPr id="6" name="Text 4"/>
+          <p:cNvSpPr txBox="1"/>
+          <p:nvPr/>
+        </p:nvSpPr>
+        <p:spPr>
+          <a:xfrm>
+            <a:off x="914400" y="3154680"/>
+            <a:ext cx="1965960" cy="731520"/>
+          </a:xfrm>
+          <a:prstGeom prst="rect">
+            <a:avLst/>
+          </a:prstGeom>
+          <a:noFill/>
+          <a:ln/>
+        </p:spPr>
+        <p:txBody>
+          <a:bodyPr wrap="square" lIns="0" tIns="0" rIns="0" bIns="0" rtlCol="0" anchor="ctr"/>
+          <a:lstStyle/>
+          <a:p>
+            <a:pPr indent="0" marL="0">
+              <a:lnSpc>
+                <a:spcPct val="120000"/>
+              </a:lnSpc>
+              <a:buNone/>
+            </a:pPr>
+            <a:r>
+              <a:rPr lang="en-US" sz="1300" dirty="0">
+                <a:solidFill>
+                  <a:srgbClr val="6A7278"/>
+                </a:solidFill>
+                <a:latin typeface="Calibri" pitchFamily="34" charset="0"/>
+                <a:ea typeface="Calibri" pitchFamily="34" charset="-122"/>
+                <a:cs typeface="Calibri" pitchFamily="34" charset="-120"/>
+              </a:rPr>
+              <a:t>Teachers committed</a:t>
+            </a:r>
+            <a:endParaRPr lang="en-US" sz="1300" dirty="0"/>
+          </a:p>
+        </p:txBody>
+      </p:sp>
+      <p:sp>
+        <p:nvSpPr>
+          <p:cNvPr id="7" name="Shape 5"/>
+          <p:cNvSpPr/>
+          <p:nvPr/>
+        </p:nvSpPr>
+        <p:spPr>
+          <a:xfrm>
+            <a:off x="3410712" y="1783080"/>
+            <a:ext cx="2514600" cy="2286000"/>
+          </a:xfrm>
+          <a:prstGeom prst="roundRect">
+            <a:avLst>
+              <a:gd name="adj" fmla="val 4000"/>
+            </a:avLst>
+          </a:prstGeom>
+          <a:solidFill>
+            <a:srgbClr val="F7F9F8"/>
+          </a:solidFill>
+          <a:ln/>
+          <a:effectLst>
+            <a:outerShdw sx="100000" sy="100000" kx="0" ky="0" algn="bl" rotWithShape="0" blurRad="127000" dist="25400" dir="5400000">
+              <a:srgbClr val="000000">
+                <a:alpha val="8000"/>
+              </a:srgbClr>
+            </a:outerShdw>
+          </a:effectLst>
+        </p:spPr>
+      </p:sp>
+      <p:sp>
+        <p:nvSpPr>
+          <p:cNvPr id="8" name="Text 6"/>
+          <p:cNvSpPr txBox="1"/>
+          <p:nvPr/>
+        </p:nvSpPr>
+        <p:spPr>
+          <a:xfrm>
+            <a:off x="3685032" y="2167128"/>
+            <a:ext cx="1965960" cy="914400"/>
+          </a:xfrm>
+          <a:prstGeom prst="rect">
+            <a:avLst/>
+          </a:prstGeom>
+          <a:noFill/>
+          <a:ln/>
+        </p:spPr>
+        <p:txBody>
+          <a:bodyPr wrap="square" lIns="0" tIns="0" rIns="0" bIns="0" rtlCol="0" anchor="ctr"/>
+          <a:lstStyle/>
+          <a:p>
+            <a:pPr indent="0" marL="0">
+              <a:buNone/>
+            </a:pPr>
+            <a:r>
+              <a:rPr lang="en-US" sz="4800" b="1" dirty="0">
+                <a:solidFill>
+                  <a:srgbClr val="0D1B2A"/>
+                </a:solidFill>
+                <a:latin typeface="Cambria" pitchFamily="34" charset="0"/>
+                <a:ea typeface="Cambria" pitchFamily="34" charset="-122"/>
+                <a:cs typeface="Cambria" pitchFamily="34" charset="-120"/>
+              </a:rPr>
+              <a:t>—</a:t>
+            </a:r>
+            <a:endParaRPr lang="en-US" sz="4800" dirty="0"/>
+          </a:p>
+        </p:txBody>
+      </p:sp>
+      <p:sp>
+        <p:nvSpPr>
+          <p:cNvPr id="9" name="Text 7"/>
+          <p:cNvSpPr txBox="1"/>
+          <p:nvPr/>
+        </p:nvSpPr>
+        <p:spPr>
+          <a:xfrm>
+            <a:off x="3685032" y="3154680"/>
+            <a:ext cx="1965960" cy="731520"/>
+          </a:xfrm>
+          <a:prstGeom prst="rect">
+            <a:avLst/>
+          </a:prstGeom>
+          <a:noFill/>
+          <a:ln/>
+        </p:spPr>
+        <p:txBody>
+          <a:bodyPr wrap="square" lIns="0" tIns="0" rIns="0" bIns="0" rtlCol="0" anchor="ctr"/>
+          <a:lstStyle/>
+          <a:p>
+            <a:pPr indent="0" marL="0">
+              <a:lnSpc>
+                <a:spcPct val="120000"/>
+              </a:lnSpc>
+              <a:buNone/>
+            </a:pPr>
+            <a:r>
+              <a:rPr lang="en-US" sz="1300" dirty="0">
+                <a:solidFill>
+                  <a:srgbClr val="6A7278"/>
+                </a:solidFill>
+                <a:latin typeface="Calibri" pitchFamily="34" charset="0"/>
+                <a:ea typeface="Calibri" pitchFamily="34" charset="-122"/>
+                <a:cs typeface="Calibri" pitchFamily="34" charset="-120"/>
+              </a:rPr>
+              <a:t>Courses published</a:t>
+            </a:r>
+            <a:endParaRPr lang="en-US" sz="1300" dirty="0"/>
+          </a:p>
+        </p:txBody>
+      </p:sp>
+      <p:sp>
+        <p:nvSpPr>
+          <p:cNvPr id="10" name="Shape 8"/>
+          <p:cNvSpPr/>
+          <p:nvPr/>
+        </p:nvSpPr>
+        <p:spPr>
+          <a:xfrm>
+            <a:off x="6181344" y="1783080"/>
+            <a:ext cx="2514600" cy="2286000"/>
+          </a:xfrm>
+          <a:prstGeom prst="roundRect">
+            <a:avLst>
+              <a:gd name="adj" fmla="val 4000"/>
+            </a:avLst>
+          </a:prstGeom>
+          <a:solidFill>
+            <a:srgbClr val="F7F9F8"/>
+          </a:solidFill>
+          <a:ln/>
+          <a:effectLst>
+            <a:outerShdw sx="100000" sy="100000" kx="0" ky="0" algn="bl" rotWithShape="0" blurRad="127000" dist="25400" dir="5400000">
+              <a:srgbClr val="000000">
+                <a:alpha val="8000"/>
+              </a:srgbClr>
+            </a:outerShdw>
+          </a:effectLst>
+        </p:spPr>
+      </p:sp>
+      <p:sp>
+        <p:nvSpPr>
+          <p:cNvPr id="11" name="Text 9"/>
+          <p:cNvSpPr txBox="1"/>
+          <p:nvPr/>
+        </p:nvSpPr>
+        <p:spPr>
+          <a:xfrm>
+            <a:off x="6455664" y="2167128"/>
+            <a:ext cx="1965960" cy="914400"/>
+          </a:xfrm>
+          <a:prstGeom prst="rect">
+            <a:avLst/>
+          </a:prstGeom>
+          <a:noFill/>
+          <a:ln/>
+        </p:spPr>
+        <p:txBody>
+          <a:bodyPr wrap="square" lIns="0" tIns="0" rIns="0" bIns="0" rtlCol="0" anchor="ctr"/>
+          <a:lstStyle/>
+          <a:p>
+            <a:pPr indent="0" marL="0">
+              <a:buNone/>
+            </a:pPr>
+            <a:r>
+              <a:rPr lang="en-US" sz="4800" b="1" dirty="0">
+                <a:solidFill>
+                  <a:srgbClr val="0D1B2A"/>
+                </a:solidFill>
+                <a:latin typeface="Cambria" pitchFamily="34" charset="0"/>
+                <a:ea typeface="Cambria" pitchFamily="34" charset="-122"/>
+                <a:cs typeface="Cambria" pitchFamily="34" charset="-120"/>
+              </a:rPr>
+              <a:t>—</a:t>
+            </a:r>
+            <a:endParaRPr lang="en-US" sz="4800" dirty="0"/>
+          </a:p>
+        </p:txBody>
+      </p:sp>
+      <p:sp>
+        <p:nvSpPr>
+          <p:cNvPr id="12" name="Text 10"/>
+          <p:cNvSpPr txBox="1"/>
+          <p:nvPr/>
+        </p:nvSpPr>
+        <p:spPr>
+          <a:xfrm>
+            <a:off x="6455664" y="3154680"/>
+            <a:ext cx="1965960" cy="731520"/>
+          </a:xfrm>
+          <a:prstGeom prst="rect">
+            <a:avLst/>
+          </a:prstGeom>
+          <a:noFill/>
+          <a:ln/>
+        </p:spPr>
+        <p:txBody>
+          <a:bodyPr wrap="square" lIns="0" tIns="0" rIns="0" bIns="0" rtlCol="0" anchor="ctr"/>
+          <a:lstStyle/>
+          <a:p>
+            <a:pPr indent="0" marL="0">
+              <a:lnSpc>
+                <a:spcPct val="120000"/>
+              </a:lnSpc>
+              <a:buNone/>
+            </a:pPr>
+            <a:r>
+              <a:rPr lang="en-US" sz="1300" dirty="0">
+                <a:solidFill>
+                  <a:srgbClr val="6A7278"/>
+                </a:solidFill>
+                <a:latin typeface="Calibri" pitchFamily="34" charset="0"/>
+                <a:ea typeface="Calibri" pitchFamily="34" charset="-122"/>
+                <a:cs typeface="Calibri" pitchFamily="34" charset="-120"/>
+              </a:rPr>
+              <a:t>Paying learners</a:t>
+            </a:r>
+            <a:endParaRPr lang="en-US" sz="1300" dirty="0"/>
+          </a:p>
+        </p:txBody>
+      </p:sp>
+      <p:sp>
+        <p:nvSpPr>
+          <p:cNvPr id="13" name="Shape 11"/>
+          <p:cNvSpPr/>
+          <p:nvPr/>
+        </p:nvSpPr>
+        <p:spPr>
+          <a:xfrm>
+            <a:off x="8951976" y="1783080"/>
+            <a:ext cx="2514600" cy="2286000"/>
+          </a:xfrm>
+          <a:prstGeom prst="roundRect">
+            <a:avLst>
+              <a:gd name="adj" fmla="val 4000"/>
+            </a:avLst>
+          </a:prstGeom>
+          <a:solidFill>
+            <a:srgbClr val="F7F9F8"/>
+          </a:solidFill>
+          <a:ln/>
+          <a:effectLst>
+            <a:outerShdw sx="100000" sy="100000" kx="0" ky="0" algn="bl" rotWithShape="0" blurRad="127000" dist="25400" dir="5400000">
+              <a:srgbClr val="000000">
+                <a:alpha val="8000"/>
+              </a:srgbClr>
+            </a:outerShdw>
+          </a:effectLst>
+        </p:spPr>
+      </p:sp>
+      <p:sp>
+        <p:nvSpPr>
+          <p:cNvPr id="14" name="Text 12"/>
+          <p:cNvSpPr txBox="1"/>
+          <p:nvPr/>
+        </p:nvSpPr>
+        <p:spPr>
+          <a:xfrm>
+            <a:off x="9226296" y="2167128"/>
+            <a:ext cx="1965960" cy="914400"/>
+          </a:xfrm>
+          <a:prstGeom prst="rect">
+            <a:avLst/>
+          </a:prstGeom>
+          <a:noFill/>
+          <a:ln/>
+        </p:spPr>
+        <p:txBody>
+          <a:bodyPr wrap="square" lIns="0" tIns="0" rIns="0" bIns="0" rtlCol="0" anchor="ctr"/>
+          <a:lstStyle/>
+          <a:p>
+            <a:pPr indent="0" marL="0">
+              <a:buNone/>
+            </a:pPr>
+            <a:r>
+              <a:rPr lang="en-US" sz="4800" b="1" dirty="0">
+                <a:solidFill>
+                  <a:srgbClr val="0D1B2A"/>
+                </a:solidFill>
+                <a:latin typeface="Cambria" pitchFamily="34" charset="0"/>
+                <a:ea typeface="Cambria" pitchFamily="34" charset="-122"/>
+                <a:cs typeface="Cambria" pitchFamily="34" charset="-120"/>
+              </a:rPr>
+              <a:t>—</a:t>
+            </a:r>
+            <a:endParaRPr lang="en-US" sz="4800" dirty="0"/>
+          </a:p>
+        </p:txBody>
+      </p:sp>
+      <p:sp>
+        <p:nvSpPr>
+          <p:cNvPr id="15" name="Text 13"/>
+          <p:cNvSpPr txBox="1"/>
+          <p:nvPr/>
+        </p:nvSpPr>
+        <p:spPr>
+          <a:xfrm>
+            <a:off x="9226296" y="3154680"/>
+            <a:ext cx="1965960" cy="731520"/>
+          </a:xfrm>
+          <a:prstGeom prst="rect">
+            <a:avLst/>
+          </a:prstGeom>
+          <a:noFill/>
+          <a:ln/>
+        </p:spPr>
+        <p:txBody>
+          <a:bodyPr wrap="square" lIns="0" tIns="0" rIns="0" bIns="0" rtlCol="0" anchor="ctr"/>
+          <a:lstStyle/>
+          <a:p>
+            <a:pPr indent="0" marL="0">
+              <a:lnSpc>
+                <a:spcPct val="120000"/>
+              </a:lnSpc>
+              <a:buNone/>
+            </a:pPr>
+            <a:r>
+              <a:rPr lang="en-US" sz="1300" dirty="0">
+                <a:solidFill>
+                  <a:srgbClr val="6A7278"/>
+                </a:solidFill>
+                <a:latin typeface="Calibri" pitchFamily="34" charset="0"/>
+                <a:ea typeface="Calibri" pitchFamily="34" charset="-122"/>
+                <a:cs typeface="Calibri" pitchFamily="34" charset="-120"/>
+              </a:rPr>
+              <a:t>Gross merchandise value</a:t>
+            </a:r>
+            <a:endParaRPr lang="en-US" sz="1300" dirty="0"/>
+          </a:p>
+        </p:txBody>
+      </p:sp>
+      <p:sp>
+        <p:nvSpPr>
+          <p:cNvPr id="16" name="Shape 14"/>
+          <p:cNvSpPr/>
+          <p:nvPr/>
+        </p:nvSpPr>
+        <p:spPr>
+          <a:xfrm>
+            <a:off x="640080" y="4389120"/>
+            <a:ext cx="10881360" cy="1371600"/>
+          </a:xfrm>
+          <a:prstGeom prst="roundRect">
+            <a:avLst>
+              <a:gd name="adj" fmla="val 6667"/>
+            </a:avLst>
+          </a:prstGeom>
+          <a:solidFill>
+            <a:srgbClr val="E6F2ED"/>
+          </a:solidFill>
+          <a:ln/>
+          <a:effectLst>
+            <a:outerShdw sx="100000" sy="100000" kx="0" ky="0" algn="bl" rotWithShape="0" blurRad="127000" dist="25400" dir="5400000">
+              <a:srgbClr val="000000">
+                <a:alpha val="8000"/>
+              </a:srgbClr>
+            </a:outerShdw>
+          </a:effectLst>
+        </p:spPr>
+      </p:sp>
+      <p:sp>
+        <p:nvSpPr>
+          <p:cNvPr id="17" name="Text 15"/>
+          <p:cNvSpPr txBox="1"/>
+          <p:nvPr/>
+        </p:nvSpPr>
+        <p:spPr>
+          <a:xfrm>
+            <a:off x="1005840" y="4572000"/>
             <a:ext cx="10149840" cy="365760"/>
           </a:xfrm>
           <a:prstGeom prst="rect">
@@ -7087,7 +8059,46 @@
               <a:buNone/>
             </a:pPr>
             <a:r>
-              <a:rPr lang="en-US" sz="1600" b="1" dirty="0">
+              <a:rPr lang="en-US" sz="1500" b="1" dirty="0">
+                <a:solidFill>
+                  <a:srgbClr val="236B50"/>
+                </a:solidFill>
+                <a:latin typeface="Calibri" pitchFamily="34" charset="0"/>
+                <a:ea typeface="Calibri" pitchFamily="34" charset="-122"/>
+                <a:cs typeface="Calibri" pitchFamily="34" charset="-120"/>
+              </a:rPr>
+              <a:t>Milestones to first revenue</a:t>
+            </a:r>
+            <a:endParaRPr lang="en-US" sz="1500" dirty="0"/>
+          </a:p>
+        </p:txBody>
+      </p:sp>
+      <p:sp>
+        <p:nvSpPr>
+          <p:cNvPr id="18" name="Text 16"/>
+          <p:cNvSpPr txBox="1"/>
+          <p:nvPr/>
+        </p:nvSpPr>
+        <p:spPr>
+          <a:xfrm>
+            <a:off x="1005840" y="4983480"/>
+            <a:ext cx="10149840" cy="548640"/>
+          </a:xfrm>
+          <a:prstGeom prst="rect">
+            <a:avLst/>
+          </a:prstGeom>
+          <a:noFill/>
+          <a:ln/>
+        </p:spPr>
+        <p:txBody>
+          <a:bodyPr wrap="square" lIns="0" tIns="0" rIns="0" bIns="0" rtlCol="0" anchor="ctr"/>
+          <a:lstStyle/>
+          <a:p>
+            <a:pPr indent="0" marL="0">
+              <a:buNone/>
+            </a:pPr>
+            <a:r>
+              <a:rPr lang="en-US" sz="1400" dirty="0">
                 <a:solidFill>
                   <a:srgbClr val="0D1B2A"/>
                 </a:solidFill>
@@ -7095,154 +8106,9 @@
                 <a:ea typeface="Calibri" pitchFamily="34" charset="-122"/>
                 <a:cs typeface="Calibri" pitchFamily="34" charset="-120"/>
               </a:rPr>
-              <a:t>Until there are numbers, show evidence instead</a:t>
-            </a:r>
-            <a:endParaRPr lang="en-US" sz="1600" dirty="0"/>
-          </a:p>
-        </p:txBody>
-      </p:sp>
-      <p:sp>
-        <p:nvSpPr>
-          <p:cNvPr id="8" name="Text 6"/>
-          <p:cNvSpPr txBox="1"/>
-          <p:nvPr/>
-        </p:nvSpPr>
-        <p:spPr>
-          <a:xfrm>
-            <a:off x="1005840" y="2971800"/>
-            <a:ext cx="10058400" cy="2103120"/>
-          </a:xfrm>
-          <a:prstGeom prst="rect">
-            <a:avLst/>
-          </a:prstGeom>
-          <a:noFill/>
-          <a:ln/>
-        </p:spPr>
-        <p:txBody>
-          <a:bodyPr wrap="square" lIns="0" tIns="0" rIns="0" bIns="0" rtlCol="0" anchor="ctr"/>
-          <a:lstStyle/>
-          <a:p>
-            <a:pPr marL="342900" indent="-342900">
-              <a:spcAft>
-                <a:spcPts val="1000"/>
-              </a:spcAft>
-              <a:buSzPct val="100000"/>
-              <a:buChar char="•"/>
-            </a:pPr>
-            <a:r>
-              <a:rPr lang="en-US" sz="1350" dirty="0">
-                <a:solidFill>
-                  <a:srgbClr val="0D1B2A"/>
-                </a:solidFill>
-                <a:latin typeface="Calibri" pitchFamily="34" charset="0"/>
-                <a:ea typeface="Calibri" pitchFamily="34" charset="-122"/>
-                <a:cs typeface="Calibri" pitchFamily="34" charset="-120"/>
-              </a:rPr>
-              <a:t>Teachers who have committed to publish at launch, by name and subject</a:t>
-            </a:r>
-            <a:endParaRPr lang="en-US" sz="1350" dirty="0"/>
-          </a:p>
-          <a:p>
-            <a:pPr marL="342900" indent="-342900">
-              <a:spcAft>
-                <a:spcPts val="1000"/>
-              </a:spcAft>
-              <a:buSzPct val="100000"/>
-              <a:buChar char="•"/>
-            </a:pPr>
-            <a:r>
-              <a:rPr lang="en-US" sz="1350" dirty="0">
-                <a:solidFill>
-                  <a:srgbClr val="0D1B2A"/>
-                </a:solidFill>
-                <a:latin typeface="Calibri" pitchFamily="34" charset="0"/>
-                <a:ea typeface="Calibri" pitchFamily="34" charset="-122"/>
-                <a:cs typeface="Calibri" pitchFamily="34" charset="-120"/>
-              </a:rPr>
-              <a:t>Letters of intent, or a waiting list with real sign-ups</a:t>
-            </a:r>
-            <a:endParaRPr lang="en-US" sz="1350" dirty="0"/>
-          </a:p>
-          <a:p>
-            <a:pPr marL="342900" indent="-342900">
-              <a:spcAft>
-                <a:spcPts val="1000"/>
-              </a:spcAft>
-              <a:buSzPct val="100000"/>
-              <a:buChar char="•"/>
-            </a:pPr>
-            <a:r>
-              <a:rPr lang="en-US" sz="1350" dirty="0">
-                <a:solidFill>
-                  <a:srgbClr val="0D1B2A"/>
-                </a:solidFill>
-                <a:latin typeface="Calibri" pitchFamily="34" charset="0"/>
-                <a:ea typeface="Calibri" pitchFamily="34" charset="-122"/>
-                <a:cs typeface="Calibri" pitchFamily="34" charset="-120"/>
-              </a:rPr>
-              <a:t>A pilot cohort: one teacher, one course, real money collected</a:t>
-            </a:r>
-            <a:endParaRPr lang="en-US" sz="1350" dirty="0"/>
-          </a:p>
-          <a:p>
-            <a:pPr marL="342900" indent="-342900">
-              <a:spcAft>
-                <a:spcPts val="1000"/>
-              </a:spcAft>
-              <a:buSzPct val="100000"/>
-              <a:buChar char="•"/>
-            </a:pPr>
-            <a:r>
-              <a:rPr lang="en-US" sz="1350" dirty="0">
-                <a:solidFill>
-                  <a:srgbClr val="0D1B2A"/>
-                </a:solidFill>
-                <a:latin typeface="Calibri" pitchFamily="34" charset="0"/>
-                <a:ea typeface="Calibri" pitchFamily="34" charset="-122"/>
-                <a:cs typeface="Calibri" pitchFamily="34" charset="-120"/>
-              </a:rPr>
-              <a:t>Pre-orders — the strongest possible signal before launch</a:t>
-            </a:r>
-            <a:endParaRPr lang="en-US" sz="1350" dirty="0"/>
-          </a:p>
-        </p:txBody>
-      </p:sp>
-      <p:sp>
-        <p:nvSpPr>
-          <p:cNvPr id="9" name="Text 7"/>
-          <p:cNvSpPr txBox="1"/>
-          <p:nvPr/>
-        </p:nvSpPr>
-        <p:spPr>
-          <a:xfrm>
-            <a:off x="640080" y="5897880"/>
-            <a:ext cx="10881360" cy="548640"/>
-          </a:xfrm>
-          <a:prstGeom prst="rect">
-            <a:avLst/>
-          </a:prstGeom>
-          <a:noFill/>
-          <a:ln/>
-        </p:spPr>
-        <p:txBody>
-          <a:bodyPr wrap="square" rtlCol="0" anchor="ctr"/>
-          <a:lstStyle/>
-          <a:p>
-            <a:pPr indent="0" marL="0">
-              <a:buNone/>
-            </a:pPr>
-            <a:r>
-              <a:rPr lang="en-US" sz="1300" i="1" dirty="0">
-                <a:solidFill>
-                  <a:srgbClr val="6A7278"/>
-                </a:solidFill>
-                <a:latin typeface="Calibri" pitchFamily="34" charset="0"/>
-                <a:ea typeface="Calibri" pitchFamily="34" charset="-122"/>
-                <a:cs typeface="Calibri" pitchFamily="34" charset="-120"/>
-              </a:rPr>
-              <a:t>One real teacher with ten paying students beats any projection. Get that before raising if you possibly can.</a:t>
-            </a:r>
-            <a:endParaRPr lang="en-US" sz="1300" dirty="0"/>
+              <a:t>Teacher cohort recruited  ·  first paid course live  ·  payout completed end to end</a:t>
+            </a:r>
+            <a:endParaRPr lang="en-US" sz="1400" dirty="0"/>
           </a:p>
         </p:txBody>
       </p:sp>
@@ -7343,7 +8209,7 @@
                 <a:ea typeface="Calibri" pitchFamily="34" charset="-122"/>
                 <a:cs typeface="Calibri" pitchFamily="34" charset="-120"/>
               </a:rPr>
-              <a:t>Honestly placed. We lose on catalogue and brand, and win on economics and reach.</a:t>
+              <a:t>Where we lead, and where we do not.</a:t>
             </a:r>
             <a:endParaRPr lang="en-US" sz="1500" dirty="0"/>
           </a:p>

</xml_diff>